<commit_message>
Add sand heat map to presentation and update documentation
Adds a new slide with a sand heat map to the presentation, updates the walkthrough PDF with talking points for the new slide, and adjusts slide counts in the presentation and documentation.

Replit-Commit-Author: Agent
Replit-Commit-Session-Id: 3a4767ff-c75a-4e3e-9c7f-f9dc0bddbc91
Replit-Commit-Checkpoint-Type: full_checkpoint
Replit-Commit-Event-Id: 2925c3f2-46d0-42c9-88ad-543a8e879697
Replit-Commit-Screenshot-Url: https://storage.googleapis.com/screenshot-production-us-central1/1f45a947-55e5-40a2-ac23-b09959702130/3a4767ff-c75a-4e3e-9c7f-f9dc0bddbc91/4iDkRdK
Replit-Helium-Checkpoint-Created: true
</commit_message>
<xml_diff>
--- a/Brain_Oil.pptx
+++ b/Brain_Oil.pptx
@@ -11,6 +11,7 @@
     <p:sldId id="259" r:id="rId10"/>
     <p:sldId id="260" r:id="rId11"/>
     <p:sldId id="261" r:id="rId12"/>
+    <p:sldId id="270" r:id="rId21"/>
     <p:sldId id="262" r:id="rId13"/>
     <p:sldId id="263" r:id="rId14"/>
     <p:sldId id="264" r:id="rId15"/>
@@ -4176,6 +4177,127 @@
             </a:pPr>
             <a:r>
               <a:t>• Energy AI Hackathon 2026</a:t>
+            </a:r>
+          </a:p>
+        </p:txBody>
+      </p:sp>
+    </p:spTree>
+  </p:cSld>
+  <p:clrMapOvr>
+    <a:masterClrMapping/>
+  </p:clrMapOvr>
+</p:sld>
+</file>
+
+<file path=ppt/slides/slide15.xml><?xml version="1.0" encoding="utf-8"?>
+<p:sld xmlns:a="http://schemas.openxmlformats.org/drawingml/2006/main" xmlns:p="http://schemas.openxmlformats.org/presentationml/2006/main" xmlns:r="http://schemas.openxmlformats.org/officeDocument/2006/relationships">
+  <p:cSld>
+    <p:spTree>
+      <p:nvGrpSpPr>
+        <p:cNvPr id="1" name=""/>
+        <p:cNvGrpSpPr/>
+        <p:nvPr/>
+      </p:nvGrpSpPr>
+      <p:grpSpPr/>
+      <p:sp>
+        <p:nvSpPr>
+          <p:cNvPr id="2" name="Title 1"/>
+          <p:cNvSpPr>
+            <a:spLocks noGrp="1"/>
+          </p:cNvSpPr>
+          <p:nvPr>
+            <p:ph type="title"/>
+          </p:nvPr>
+        </p:nvSpPr>
+        <p:spPr/>
+        <p:txBody>
+          <a:bodyPr/>
+          <a:lstStyle/>
+          <a:p/>
+        </p:txBody>
+      </p:sp>
+      <p:sp>
+        <p:nvSpPr>
+          <p:cNvPr id="3" name="TextBox 2"/>
+          <p:cNvSpPr txBox="1"/>
+          <p:nvPr/>
+        </p:nvSpPr>
+        <p:spPr>
+          <a:xfrm>
+            <a:off x="457200" y="274320"/>
+            <a:ext cx="8229600" cy="731520"/>
+          </a:xfrm>
+          <a:prstGeom prst="rect">
+            <a:avLst/>
+          </a:prstGeom>
+          <a:noFill/>
+        </p:spPr>
+        <p:txBody>
+          <a:bodyPr wrap="none">
+            <a:spAutoFit/>
+          </a:bodyPr>
+          <a:lstStyle/>
+          <a:p>
+            <a:pPr algn="ctr">
+              <a:defRPr sz="2800" b="1"/>
+            </a:pPr>
+            <a:r>
+              <a:t>Spatial Analysis: Sand Proportion &amp; Production</a:t>
+            </a:r>
+          </a:p>
+        </p:txBody>
+      </p:sp>
+      <p:pic>
+        <p:nvPicPr>
+          <p:cNvPr id="4" name="Picture 3" descr="sand_heat_map.png"/>
+          <p:cNvPicPr>
+            <a:picLocks noChangeAspect="1"/>
+          </p:cNvPicPr>
+          <p:nvPr/>
+        </p:nvPicPr>
+        <p:blipFill>
+          <a:blip r:embed="rId2"/>
+          <a:stretch>
+            <a:fillRect/>
+          </a:stretch>
+        </p:blipFill>
+        <p:spPr>
+          <a:xfrm>
+            <a:off x="1371600" y="1097280"/>
+            <a:ext cx="6400800" cy="4846320"/>
+          </a:xfrm>
+          <a:prstGeom prst="rect">
+            <a:avLst/>
+          </a:prstGeom>
+        </p:spPr>
+      </p:pic>
+      <p:sp>
+        <p:nvSpPr>
+          <p:cNvPr id="5" name="TextBox 4"/>
+          <p:cNvSpPr txBox="1"/>
+          <p:nvPr/>
+        </p:nvSpPr>
+        <p:spPr>
+          <a:xfrm>
+            <a:off x="274320" y="6035040"/>
+            <a:ext cx="8595360" cy="548640"/>
+          </a:xfrm>
+          <a:prstGeom prst="rect">
+            <a:avLst/>
+          </a:prstGeom>
+          <a:noFill/>
+        </p:spPr>
+        <p:txBody>
+          <a:bodyPr wrap="none">
+            <a:spAutoFit/>
+          </a:bodyPr>
+          <a:lstStyle/>
+          <a:p>
+            <a:pPr algn="ctr">
+              <a:defRPr sz="1400" i="1"/>
+            </a:pPr>
+            <a:r>
+              <a:t>Key Insight: Higher sand proportion (yellow) correlates with higher oil production (green/yellow markers)</a:t>
             </a:r>
           </a:p>
         </p:txBody>

</xml_diff>

<commit_message>
Update presentation to meet official hackathon requirements
Adjusted the presentation structure and supporting documents to adhere to the official 6-slide hackathon template, including updating the PowerPoint, walkthrough PDF, and README files.

Replit-Commit-Author: Agent
Replit-Commit-Session-Id: 3a4767ff-c75a-4e3e-9c7f-f9dc0bddbc91
Replit-Commit-Checkpoint-Type: full_checkpoint
Replit-Commit-Event-Id: a2fbf785-8cf0-4ed2-8c32-b4810111c047
Replit-Commit-Screenshot-Url: https://storage.googleapis.com/screenshot-production-us-central1/1f45a947-55e5-40a2-ac23-b09959702130/3a4767ff-c75a-4e3e-9c7f-f9dc0bddbc91/1igt8LE
Replit-Helium-Checkpoint-Created: true
</commit_message>
<xml_diff>
--- a/Brain_Oil.pptx
+++ b/Brain_Oil.pptx
@@ -11,15 +11,6 @@
     <p:sldId id="259" r:id="rId10"/>
     <p:sldId id="260" r:id="rId11"/>
     <p:sldId id="261" r:id="rId12"/>
-    <p:sldId id="270" r:id="rId21"/>
-    <p:sldId id="262" r:id="rId13"/>
-    <p:sldId id="263" r:id="rId14"/>
-    <p:sldId id="264" r:id="rId15"/>
-    <p:sldId id="265" r:id="rId16"/>
-    <p:sldId id="266" r:id="rId17"/>
-    <p:sldId id="267" r:id="rId18"/>
-    <p:sldId id="268" r:id="rId19"/>
-    <p:sldId id="269" r:id="rId20"/>
   </p:sldIdLst>
   <p:sldSz cx="9144000" cy="6858000" type="screen4x3"/>
   <p:notesSz cx="6858000" cy="9144000"/>
@@ -3110,7 +3101,7 @@
         </p:nvSpPr>
         <p:spPr>
           <a:xfrm>
-            <a:off x="457200" y="1828800"/>
+            <a:off x="457200" y="1371600"/>
             <a:ext cx="8229600" cy="914400"/>
           </a:xfrm>
           <a:prstGeom prst="rect">
@@ -3125,10 +3116,10 @@
           <a:lstStyle/>
           <a:p>
             <a:pPr algn="ctr">
-              <a:defRPr sz="4400" b="1"/>
-            </a:pPr>
-            <a:r>
-              <a:t>Brain_Oil</a:t>
+              <a:defRPr sz="4000" b="1"/>
+            </a:pPr>
+            <a:r>
+              <a:t>Oil Production Prediction</a:t>
             </a:r>
           </a:p>
         </p:txBody>
@@ -3141,7 +3132,7 @@
         </p:nvSpPr>
         <p:spPr>
           <a:xfrm>
-            <a:off x="457200" y="2926080"/>
+            <a:off x="457200" y="2377440"/>
             <a:ext cx="8229600" cy="457200"/>
           </a:xfrm>
           <a:prstGeom prst="rect">
@@ -3156,10 +3147,10 @@
           <a:lstStyle/>
           <a:p>
             <a:pPr algn="ctr">
-              <a:defRPr sz="2400"/>
-            </a:pPr>
-            <a:r>
-              <a:t>Predicting 3-Year Cumulative Oil Production with Uncertainty</a:t>
+              <a:defRPr sz="2000"/>
+            </a:pPr>
+            <a:r>
+              <a:t>Energy AI Hackathon 2026 - January 25th, 2026</a:t>
             </a:r>
           </a:p>
         </p:txBody>
@@ -3172,8 +3163,8 @@
         </p:nvSpPr>
         <p:spPr>
           <a:xfrm>
-            <a:off x="457200" y="3840480"/>
-            <a:ext cx="8229600" cy="914400"/>
+            <a:off x="457200" y="3200400"/>
+            <a:ext cx="8229600" cy="365760"/>
           </a:xfrm>
           <a:prstGeom prst="rect">
             <a:avLst/>
@@ -3187,10 +3178,10 @@
           <a:lstStyle/>
           <a:p>
             <a:pPr algn="ctr">
-              <a:defRPr sz="1800"/>
-            </a:pPr>
-            <a:r>
-              <a:t>Kailasadatta Boggaram | Jayanth Damodaran | Bilal Shihab | Carlos Fabela</a:t>
+              <a:defRPr sz="2400" b="1"/>
+            </a:pPr>
+            <a:r>
+              <a:t>Team Brain Oil</a:t>
             </a:r>
           </a:p>
         </p:txBody>
@@ -3203,8 +3194,8 @@
         </p:nvSpPr>
         <p:spPr>
           <a:xfrm>
-            <a:off x="457200" y="4572000"/>
-            <a:ext cx="8229600" cy="457200"/>
+            <a:off x="457200" y="3657600"/>
+            <a:ext cx="8229600" cy="914400"/>
           </a:xfrm>
           <a:prstGeom prst="rect">
             <a:avLst/>
@@ -3221,7 +3212,7 @@
               <a:defRPr sz="1600"/>
             </a:pPr>
             <a:r>
-              <a:t>The University of Texas at Austin</a:t>
+              <a:t>Kailasadatta Boggaram, Jayanth Damodaran, Bilal Shihab, Carlos Fabela</a:t>
             </a:r>
           </a:p>
         </p:txBody>
@@ -3234,7 +3225,7 @@
         </p:nvSpPr>
         <p:spPr>
           <a:xfrm>
-            <a:off x="457200" y="5029200"/>
+            <a:off x="457200" y="4572000"/>
             <a:ext cx="8229600" cy="457200"/>
           </a:xfrm>
           <a:prstGeom prst="rect">
@@ -3252,39 +3243,21 @@
               <a:defRPr sz="1400"/>
             </a:pPr>
             <a:r>
-              <a:t>Energy AI Hackathon 2026</a:t>
-            </a:r>
-          </a:p>
-        </p:txBody>
-      </p:sp>
-    </p:spTree>
-  </p:cSld>
-  <p:clrMapOvr>
-    <a:masterClrMapping/>
-  </p:clrMapOvr>
-</p:sld>
-</file>
-
-<file path=ppt/slides/slide10.xml><?xml version="1.0" encoding="utf-8"?>
-<p:sld xmlns:a="http://schemas.openxmlformats.org/drawingml/2006/main" xmlns:p="http://schemas.openxmlformats.org/presentationml/2006/main" xmlns:r="http://schemas.openxmlformats.org/officeDocument/2006/relationships">
-  <p:cSld>
-    <p:spTree>
-      <p:nvGrpSpPr>
-        <p:cNvPr id="1" name=""/>
-        <p:cNvGrpSpPr/>
-        <p:nvPr/>
-      </p:nvGrpSpPr>
-      <p:grpSpPr/>
-      <p:sp>
-        <p:nvSpPr>
-          <p:cNvPr id="2" name="TextBox 1"/>
+              <a:t>Hildebrand Department of Petroleum and Geosystems Engineering</a:t>
+            </a:r>
+          </a:p>
+        </p:txBody>
+      </p:sp>
+      <p:sp>
+        <p:nvSpPr>
+          <p:cNvPr id="7" name="TextBox 6"/>
           <p:cNvSpPr txBox="1"/>
           <p:nvPr/>
         </p:nvSpPr>
         <p:spPr>
           <a:xfrm>
-            <a:off x="457200" y="274320"/>
-            <a:ext cx="8229600" cy="731520"/>
+            <a:off x="457200" y="4937760"/>
+            <a:ext cx="8229600" cy="457200"/>
           </a:xfrm>
           <a:prstGeom prst="rect">
             <a:avLst/>
@@ -3297,1007 +3270,11 @@
           </a:bodyPr>
           <a:lstStyle/>
           <a:p>
-            <a:pPr>
-              <a:defRPr sz="3200" b="1"/>
-            </a:pPr>
-            <a:r>
-              <a:t>Final Model Performance</a:t>
-            </a:r>
-          </a:p>
-        </p:txBody>
-      </p:sp>
-      <p:sp>
-        <p:nvSpPr>
-          <p:cNvPr id="3" name="TextBox 2"/>
-          <p:cNvSpPr txBox="1"/>
-          <p:nvPr/>
-        </p:nvSpPr>
-        <p:spPr>
-          <a:xfrm>
-            <a:off x="457200" y="914400"/>
-            <a:ext cx="8229600" cy="457200"/>
-          </a:xfrm>
-          <a:prstGeom prst="rect">
-            <a:avLst/>
-          </a:prstGeom>
-          <a:noFill/>
-        </p:spPr>
-        <p:txBody>
-          <a:bodyPr wrap="none">
-            <a:spAutoFit/>
-          </a:bodyPr>
-          <a:lstStyle/>
-          <a:p>
-            <a:pPr>
-              <a:defRPr sz="1800" i="1"/>
-            </a:pPr>
-            <a:r>
-              <a:t>Model achieves excellent accuracy with robust cross-validation</a:t>
-            </a:r>
-          </a:p>
-        </p:txBody>
-      </p:sp>
-      <p:graphicFrame>
-        <p:nvGraphicFramePr>
-          <p:cNvPr id="4" name="Table 3"/>
-          <p:cNvGraphicFramePr>
-            <a:graphicFrameLocks noGrp="1"/>
-          </p:cNvGraphicFramePr>
-          <p:nvPr/>
-        </p:nvGraphicFramePr>
-        <p:xfrm>
-          <a:off x="457200" y="1371600"/>
-          <a:ext cx="8229600" cy="2286000"/>
-        </p:xfrm>
-        <a:graphic>
-          <a:graphicData uri="http://schemas.openxmlformats.org/drawingml/2006/table">
-            <a:tbl>
-              <a:tblPr firstRow="1" bandRow="1">
-                <a:tableStyleId>{5C22544A-7EE6-4342-B048-85BDC9FD1C3A}</a:tableStyleId>
-              </a:tblPr>
-              <a:tblGrid>
-                <a:gridCol w="2743200"/>
-                <a:gridCol w="2743200"/>
-                <a:gridCol w="2743200"/>
-              </a:tblGrid>
-              <a:tr h="457200">
-                <a:tc>
-                  <a:txBody>
-                    <a:bodyPr/>
-                    <a:lstStyle/>
-                    <a:p>
-                      <a:pPr>
-                        <a:defRPr b="1" sz="1400"/>
-                      </a:pPr>
-                      <a:r>
-                        <a:t>Metric</a:t>
-                      </a:r>
-                    </a:p>
-                  </a:txBody>
-                  <a:tcPr/>
-                </a:tc>
-                <a:tc>
-                  <a:txBody>
-                    <a:bodyPr/>
-                    <a:lstStyle/>
-                    <a:p>
-                      <a:pPr>
-                        <a:defRPr b="1" sz="1400"/>
-                      </a:pPr>
-                      <a:r>
-                        <a:t>Value</a:t>
-                      </a:r>
-                    </a:p>
-                  </a:txBody>
-                  <a:tcPr/>
-                </a:tc>
-                <a:tc>
-                  <a:txBody>
-                    <a:bodyPr/>
-                    <a:lstStyle/>
-                    <a:p>
-                      <a:pPr>
-                        <a:defRPr b="1" sz="1400"/>
-                      </a:pPr>
-                      <a:r>
-                        <a:t>Industry Benchmark</a:t>
-                      </a:r>
-                    </a:p>
-                  </a:txBody>
-                  <a:tcPr/>
-                </a:tc>
-              </a:tr>
-              <a:tr h="457200">
-                <a:tc>
-                  <a:txBody>
-                    <a:bodyPr/>
-                    <a:lstStyle/>
-                    <a:p>
-                      <a:pPr>
-                        <a:defRPr sz="1200"/>
-                      </a:pPr>
-                      <a:r>
-                        <a:t>Test R²</a:t>
-                      </a:r>
-                    </a:p>
-                  </a:txBody>
-                  <a:tcPr/>
-                </a:tc>
-                <a:tc>
-                  <a:txBody>
-                    <a:bodyPr/>
-                    <a:lstStyle/>
-                    <a:p>
-                      <a:pPr>
-                        <a:defRPr sz="1200"/>
-                      </a:pPr>
-                      <a:r>
-                        <a:t>0.9905</a:t>
-                      </a:r>
-                    </a:p>
-                  </a:txBody>
-                  <a:tcPr/>
-                </a:tc>
-                <a:tc>
-                  <a:txBody>
-                    <a:bodyPr/>
-                    <a:lstStyle/>
-                    <a:p>
-                      <a:pPr>
-                        <a:defRPr sz="1200"/>
-                      </a:pPr>
-                      <a:r>
-                        <a:t>Excellent (≥0.93)</a:t>
-                      </a:r>
-                    </a:p>
-                  </a:txBody>
-                  <a:tcPr/>
-                </a:tc>
-              </a:tr>
-              <a:tr h="457200">
-                <a:tc>
-                  <a:txBody>
-                    <a:bodyPr/>
-                    <a:lstStyle/>
-                    <a:p>
-                      <a:pPr>
-                        <a:defRPr sz="1200"/>
-                      </a:pPr>
-                      <a:r>
-                        <a:t>CV R² Mean</a:t>
-                      </a:r>
-                    </a:p>
-                  </a:txBody>
-                  <a:tcPr/>
-                </a:tc>
-                <a:tc>
-                  <a:txBody>
-                    <a:bodyPr/>
-                    <a:lstStyle/>
-                    <a:p>
-                      <a:pPr>
-                        <a:defRPr sz="1200"/>
-                      </a:pPr>
-                      <a:r>
-                        <a:t>0.9539 ± 0.0456</a:t>
-                      </a:r>
-                    </a:p>
-                  </a:txBody>
-                  <a:tcPr/>
-                </a:tc>
-                <a:tc>
-                  <a:txBody>
-                    <a:bodyPr/>
-                    <a:lstStyle/>
-                    <a:p>
-                      <a:pPr>
-                        <a:defRPr sz="1200"/>
-                      </a:pPr>
-                      <a:r>
-                        <a:t>Excellent</a:t>
-                      </a:r>
-                    </a:p>
-                  </a:txBody>
-                  <a:tcPr/>
-                </a:tc>
-              </a:tr>
-              <a:tr h="457200">
-                <a:tc>
-                  <a:txBody>
-                    <a:bodyPr/>
-                    <a:lstStyle/>
-                    <a:p>
-                      <a:pPr>
-                        <a:defRPr sz="1200"/>
-                      </a:pPr>
-                      <a:r>
-                        <a:t>Test RMSE</a:t>
-                      </a:r>
-                    </a:p>
-                  </a:txBody>
-                  <a:tcPr/>
-                </a:tc>
-                <a:tc>
-                  <a:txBody>
-                    <a:bodyPr/>
-                    <a:lstStyle/>
-                    <a:p>
-                      <a:pPr>
-                        <a:defRPr sz="1200"/>
-                      </a:pPr>
-                      <a:r>
-                        <a:t>1.57M BBL</a:t>
-                      </a:r>
-                    </a:p>
-                  </a:txBody>
-                  <a:tcPr/>
-                </a:tc>
-                <a:tc>
-                  <a:txBody>
-                    <a:bodyPr/>
-                    <a:lstStyle/>
-                    <a:p>
-                      <a:pPr>
-                        <a:defRPr sz="1200"/>
-                      </a:pPr>
-                      <a:r>
-                        <a:t>4.7% of mean (Excellent &lt;10%)</a:t>
-                      </a:r>
-                    </a:p>
-                  </a:txBody>
-                  <a:tcPr/>
-                </a:tc>
-              </a:tr>
-              <a:tr h="457200">
-                <a:tc>
-                  <a:txBody>
-                    <a:bodyPr/>
-                    <a:lstStyle/>
-                    <a:p>
-                      <a:pPr>
-                        <a:defRPr sz="1200"/>
-                      </a:pPr>
-                      <a:r>
-                        <a:t>Features Used</a:t>
-                      </a:r>
-                    </a:p>
-                  </a:txBody>
-                  <a:tcPr/>
-                </a:tc>
-                <a:tc>
-                  <a:txBody>
-                    <a:bodyPr/>
-                    <a:lstStyle/>
-                    <a:p>
-                      <a:pPr>
-                        <a:defRPr sz="1200"/>
-                      </a:pPr>
-                      <a:r>
-                        <a:t>10</a:t>
-                      </a:r>
-                    </a:p>
-                  </a:txBody>
-                  <a:tcPr/>
-                </a:tc>
-                <a:tc>
-                  <a:txBody>
-                    <a:bodyPr/>
-                    <a:lstStyle/>
-                    <a:p>
-                      <a:pPr>
-                        <a:defRPr sz="1200"/>
-                      </a:pPr>
-                      <a:r>
-                        <a:t>Optimal via stepwise selection</a:t>
-                      </a:r>
-                    </a:p>
-                  </a:txBody>
-                  <a:tcPr/>
-                </a:tc>
-              </a:tr>
-            </a:tbl>
-          </a:graphicData>
-        </a:graphic>
-      </p:graphicFrame>
-    </p:spTree>
-  </p:cSld>
-  <p:clrMapOvr>
-    <a:masterClrMapping/>
-  </p:clrMapOvr>
-</p:sld>
-</file>
-
-<file path=ppt/slides/slide11.xml><?xml version="1.0" encoding="utf-8"?>
-<p:sld xmlns:a="http://schemas.openxmlformats.org/drawingml/2006/main" xmlns:p="http://schemas.openxmlformats.org/presentationml/2006/main" xmlns:r="http://schemas.openxmlformats.org/officeDocument/2006/relationships">
-  <p:cSld>
-    <p:spTree>
-      <p:nvGrpSpPr>
-        <p:cNvPr id="1" name=""/>
-        <p:cNvGrpSpPr/>
-        <p:nvPr/>
-      </p:nvGrpSpPr>
-      <p:grpSpPr/>
-      <p:sp>
-        <p:nvSpPr>
-          <p:cNvPr id="2" name="TextBox 1"/>
-          <p:cNvSpPr txBox="1"/>
-          <p:nvPr/>
-        </p:nvSpPr>
-        <p:spPr>
-          <a:xfrm>
-            <a:off x="457200" y="274320"/>
-            <a:ext cx="8229600" cy="731520"/>
-          </a:xfrm>
-          <a:prstGeom prst="rect">
-            <a:avLst/>
-          </a:prstGeom>
-          <a:noFill/>
-        </p:spPr>
-        <p:txBody>
-          <a:bodyPr wrap="none">
-            <a:spAutoFit/>
-          </a:bodyPr>
-          <a:lstStyle/>
-          <a:p>
-            <a:pPr>
-              <a:defRPr sz="3200" b="1"/>
-            </a:pPr>
-            <a:r>
-              <a:t>Key Innovations</a:t>
-            </a:r>
-          </a:p>
-        </p:txBody>
-      </p:sp>
-      <p:sp>
-        <p:nvSpPr>
-          <p:cNvPr id="3" name="TextBox 2"/>
-          <p:cNvSpPr txBox="1"/>
-          <p:nvPr/>
-        </p:nvSpPr>
-        <p:spPr>
-          <a:xfrm>
-            <a:off x="457200" y="914400"/>
-            <a:ext cx="8229600" cy="4572000"/>
-          </a:xfrm>
-          <a:prstGeom prst="rect">
-            <a:avLst/>
-          </a:prstGeom>
-          <a:noFill/>
-        </p:spPr>
-        <p:txBody>
-          <a:bodyPr wrap="square">
-            <a:spAutoFit/>
-          </a:bodyPr>
-          <a:lstStyle/>
-          <a:p>
-            <a:pPr>
-              <a:spcBef>
-                <a:spcPts val="800"/>
-              </a:spcBef>
-              <a:spcAft>
-                <a:spcPts val="400"/>
-              </a:spcAft>
-              <a:defRPr sz="2000"/>
-            </a:pPr>
-            <a:r>
-              <a:t>• MICE imputation at depth level (before aggregation) - preserves correlations</a:t>
-            </a:r>
-          </a:p>
-          <a:p>
-            <a:pPr>
-              <a:spcBef>
-                <a:spcPts val="800"/>
-              </a:spcBef>
-              <a:spcAft>
-                <a:spcPts val="400"/>
-              </a:spcAft>
-              <a:defRPr sz="2000"/>
-            </a:pPr>
-            <a:r>
-              <a:t>• Two-stage feature selection: correlation filter + stepwise forward</a:t>
-            </a:r>
-          </a:p>
-          <a:p>
-            <a:pPr>
-              <a:spcBef>
-                <a:spcPts val="800"/>
-              </a:spcBef>
-              <a:spcAft>
-                <a:spcPts val="400"/>
-              </a:spcAft>
-              <a:defRPr sz="2000"/>
-            </a:pPr>
-            <a:r>
-              <a:t>• Best zone features capture depth heterogeneity that averages miss</a:t>
-            </a:r>
-          </a:p>
-          <a:p>
-            <a:pPr>
-              <a:spcBef>
-                <a:spcPts val="800"/>
-              </a:spcBef>
-              <a:spcAft>
-                <a:spcPts val="400"/>
-              </a:spcAft>
-              <a:defRPr sz="2000"/>
-            </a:pPr>
-            <a:r>
-              <a:t>• Systematic benchmarking: 57+ configurations tested to find optimal</a:t>
-            </a:r>
-          </a:p>
-          <a:p>
-            <a:pPr>
-              <a:spcBef>
-                <a:spcPts val="800"/>
-              </a:spcBef>
-              <a:spcAft>
-                <a:spcPts val="400"/>
-              </a:spcAft>
-              <a:defRPr sz="2000"/>
-            </a:pPr>
-            <a:r>
-              <a:t>• Bagging over residual bootstrap for uncertainty - captures model uncertainty</a:t>
-            </a:r>
-          </a:p>
-        </p:txBody>
-      </p:sp>
-    </p:spTree>
-  </p:cSld>
-  <p:clrMapOvr>
-    <a:masterClrMapping/>
-  </p:clrMapOvr>
-</p:sld>
-</file>
-
-<file path=ppt/slides/slide12.xml><?xml version="1.0" encoding="utf-8"?>
-<p:sld xmlns:a="http://schemas.openxmlformats.org/drawingml/2006/main" xmlns:p="http://schemas.openxmlformats.org/presentationml/2006/main" xmlns:r="http://schemas.openxmlformats.org/officeDocument/2006/relationships">
-  <p:cSld>
-    <p:spTree>
-      <p:nvGrpSpPr>
-        <p:cNvPr id="1" name=""/>
-        <p:cNvGrpSpPr/>
-        <p:nvPr/>
-      </p:nvGrpSpPr>
-      <p:grpSpPr/>
-      <p:sp>
-        <p:nvSpPr>
-          <p:cNvPr id="2" name="TextBox 1"/>
-          <p:cNvSpPr txBox="1"/>
-          <p:nvPr/>
-        </p:nvSpPr>
-        <p:spPr>
-          <a:xfrm>
-            <a:off x="457200" y="274320"/>
-            <a:ext cx="8229600" cy="731520"/>
-          </a:xfrm>
-          <a:prstGeom prst="rect">
-            <a:avLst/>
-          </a:prstGeom>
-          <a:noFill/>
-        </p:spPr>
-        <p:txBody>
-          <a:bodyPr wrap="none">
-            <a:spAutoFit/>
-          </a:bodyPr>
-          <a:lstStyle/>
-          <a:p>
-            <a:pPr>
-              <a:defRPr sz="3200" b="1"/>
-            </a:pPr>
-            <a:r>
-              <a:t>Key References</a:t>
-            </a:r>
-          </a:p>
-        </p:txBody>
-      </p:sp>
-      <p:sp>
-        <p:nvSpPr>
-          <p:cNvPr id="3" name="TextBox 2"/>
-          <p:cNvSpPr txBox="1"/>
-          <p:nvPr/>
-        </p:nvSpPr>
-        <p:spPr>
-          <a:xfrm>
-            <a:off x="457200" y="914400"/>
-            <a:ext cx="8229600" cy="4572000"/>
-          </a:xfrm>
-          <a:prstGeom prst="rect">
-            <a:avLst/>
-          </a:prstGeom>
-          <a:noFill/>
-        </p:spPr>
-        <p:txBody>
-          <a:bodyPr wrap="square">
-            <a:spAutoFit/>
-          </a:bodyPr>
-          <a:lstStyle/>
-          <a:p>
-            <a:pPr>
-              <a:spcBef>
-                <a:spcPts val="800"/>
-              </a:spcBef>
-              <a:spcAft>
-                <a:spcPts val="400"/>
-              </a:spcAft>
-              <a:defRPr sz="2000"/>
-            </a:pPr>
-            <a:r>
-              <a:t>• Amaefule et al. (1993) - RQI/FZI for reservoir quality, SPE</a:t>
-            </a:r>
-          </a:p>
-          <a:p>
-            <a:pPr>
-              <a:spcBef>
-                <a:spcPts val="800"/>
-              </a:spcBef>
-              <a:spcAft>
-                <a:spcPts val="400"/>
-              </a:spcAft>
-              <a:defRPr sz="2000"/>
-            </a:pPr>
-            <a:r>
-              <a:t>• Breiman (1996) - Bagging predictors, Machine Learning</a:t>
-            </a:r>
-          </a:p>
-          <a:p>
-            <a:pPr>
-              <a:spcBef>
-                <a:spcPts val="800"/>
-              </a:spcBef>
-              <a:spcAft>
-                <a:spcPts val="400"/>
-              </a:spcAft>
-              <a:defRPr sz="2000"/>
-            </a:pPr>
-            <a:r>
-              <a:t>• Hastie, Tibshirani &amp; Friedman (2009) - Elements of Statistical Learning</a:t>
-            </a:r>
-          </a:p>
-          <a:p>
-            <a:pPr>
-              <a:spcBef>
-                <a:spcPts val="800"/>
-              </a:spcBef>
-              <a:spcAft>
-                <a:spcPts val="400"/>
-              </a:spcAft>
-              <a:defRPr sz="2000"/>
-            </a:pPr>
-            <a:r>
-              <a:t>• Hoerl &amp; Kennard (1970) - Ridge Regression, Technometrics</a:t>
-            </a:r>
-          </a:p>
-          <a:p>
-            <a:pPr>
-              <a:spcBef>
-                <a:spcPts val="800"/>
-              </a:spcBef>
-              <a:spcAft>
-                <a:spcPts val="400"/>
-              </a:spcAft>
-              <a:defRPr sz="2000"/>
-            </a:pPr>
-            <a:r>
-              <a:t>• Miller (2002) - Subset Selection in Regression, Chapman &amp; Hall</a:t>
-            </a:r>
-          </a:p>
-          <a:p>
-            <a:pPr>
-              <a:spcBef>
-                <a:spcPts val="800"/>
-              </a:spcBef>
-              <a:spcAft>
-                <a:spcPts val="400"/>
-              </a:spcAft>
-              <a:defRPr sz="2000"/>
-            </a:pPr>
-            <a:r>
-              <a:t>• Van Buuren (2018) - Flexible Imputation of Missing Data, CRC Press</a:t>
-            </a:r>
-          </a:p>
-        </p:txBody>
-      </p:sp>
-    </p:spTree>
-  </p:cSld>
-  <p:clrMapOvr>
-    <a:masterClrMapping/>
-  </p:clrMapOvr>
-</p:sld>
-</file>
-
-<file path=ppt/slides/slide13.xml><?xml version="1.0" encoding="utf-8"?>
-<p:sld xmlns:a="http://schemas.openxmlformats.org/drawingml/2006/main" xmlns:p="http://schemas.openxmlformats.org/presentationml/2006/main" xmlns:r="http://schemas.openxmlformats.org/officeDocument/2006/relationships">
-  <p:cSld>
-    <p:spTree>
-      <p:nvGrpSpPr>
-        <p:cNvPr id="1" name=""/>
-        <p:cNvGrpSpPr/>
-        <p:nvPr/>
-      </p:nvGrpSpPr>
-      <p:grpSpPr/>
-      <p:sp>
-        <p:nvSpPr>
-          <p:cNvPr id="2" name="TextBox 1"/>
-          <p:cNvSpPr txBox="1"/>
-          <p:nvPr/>
-        </p:nvSpPr>
-        <p:spPr>
-          <a:xfrm>
-            <a:off x="457200" y="274320"/>
-            <a:ext cx="8229600" cy="731520"/>
-          </a:xfrm>
-          <a:prstGeom prst="rect">
-            <a:avLst/>
-          </a:prstGeom>
-          <a:noFill/>
-        </p:spPr>
-        <p:txBody>
-          <a:bodyPr wrap="none">
-            <a:spAutoFit/>
-          </a:bodyPr>
-          <a:lstStyle/>
-          <a:p>
-            <a:pPr>
-              <a:defRPr sz="3200" b="1"/>
-            </a:pPr>
-            <a:r>
-              <a:t>Conclusions</a:t>
-            </a:r>
-          </a:p>
-        </p:txBody>
-      </p:sp>
-      <p:sp>
-        <p:nvSpPr>
-          <p:cNvPr id="3" name="TextBox 2"/>
-          <p:cNvSpPr txBox="1"/>
-          <p:nvPr/>
-        </p:nvSpPr>
-        <p:spPr>
-          <a:xfrm>
-            <a:off x="457200" y="914400"/>
-            <a:ext cx="8229600" cy="4572000"/>
-          </a:xfrm>
-          <a:prstGeom prst="rect">
-            <a:avLst/>
-          </a:prstGeom>
-          <a:noFill/>
-        </p:spPr>
-        <p:txBody>
-          <a:bodyPr wrap="square">
-            <a:spAutoFit/>
-          </a:bodyPr>
-          <a:lstStyle/>
-          <a:p>
-            <a:pPr>
-              <a:spcBef>
-                <a:spcPts val="800"/>
-              </a:spcBef>
-              <a:spcAft>
-                <a:spcPts val="400"/>
-              </a:spcAft>
-              <a:defRPr sz="2000"/>
-            </a:pPr>
-            <a:r>
-              <a:t>• Ridge Regression with stepwise selection achieved R²=0.9905 on test data</a:t>
-            </a:r>
-          </a:p>
-          <a:p>
-            <a:pPr>
-              <a:spcBef>
-                <a:spcPts val="800"/>
-              </a:spcBef>
-              <a:spcAft>
-                <a:spcPts val="400"/>
-              </a:spcAft>
-              <a:defRPr sz="2000"/>
-            </a:pPr>
-            <a:r>
-              <a:t>• Regularized linear models outperform tree ensembles on small datasets</a:t>
-            </a:r>
-          </a:p>
-          <a:p>
-            <a:pPr>
-              <a:spcBef>
-                <a:spcPts val="800"/>
-              </a:spcBef>
-              <a:spcAft>
-                <a:spcPts val="400"/>
-              </a:spcAft>
-              <a:defRPr sz="2000"/>
-            </a:pPr>
-            <a:r>
-              <a:t>• MICE imputation at depth level is critical for preserving correlations</a:t>
-            </a:r>
-          </a:p>
-          <a:p>
-            <a:pPr>
-              <a:spcBef>
-                <a:spcPts val="800"/>
-              </a:spcBef>
-              <a:spcAft>
-                <a:spcPts val="400"/>
-              </a:spcAft>
-              <a:defRPr sz="2000"/>
-            </a:pPr>
-            <a:r>
-              <a:t>• Feature engineering (RQI, FZI, best zone) captures reservoir quality</a:t>
-            </a:r>
-          </a:p>
-          <a:p>
-            <a:pPr>
-              <a:spcBef>
-                <a:spcPts val="800"/>
-              </a:spcBef>
-              <a:spcAft>
-                <a:spcPts val="400"/>
-              </a:spcAft>
-              <a:defRPr sz="2000"/>
-            </a:pPr>
-            <a:r>
-              <a:t>• Bagging provides robust uncertainty quantification (100 realizations)</a:t>
-            </a:r>
-          </a:p>
-        </p:txBody>
-      </p:sp>
-    </p:spTree>
-  </p:cSld>
-  <p:clrMapOvr>
-    <a:masterClrMapping/>
-  </p:clrMapOvr>
-</p:sld>
-</file>
-
-<file path=ppt/slides/slide14.xml><?xml version="1.0" encoding="utf-8"?>
-<p:sld xmlns:a="http://schemas.openxmlformats.org/drawingml/2006/main" xmlns:p="http://schemas.openxmlformats.org/presentationml/2006/main" xmlns:r="http://schemas.openxmlformats.org/officeDocument/2006/relationships">
-  <p:cSld>
-    <p:spTree>
-      <p:nvGrpSpPr>
-        <p:cNvPr id="1" name=""/>
-        <p:cNvGrpSpPr/>
-        <p:nvPr/>
-      </p:nvGrpSpPr>
-      <p:grpSpPr/>
-      <p:sp>
-        <p:nvSpPr>
-          <p:cNvPr id="2" name="TextBox 1"/>
-          <p:cNvSpPr txBox="1"/>
-          <p:nvPr/>
-        </p:nvSpPr>
-        <p:spPr>
-          <a:xfrm>
-            <a:off x="457200" y="274320"/>
-            <a:ext cx="8229600" cy="731520"/>
-          </a:xfrm>
-          <a:prstGeom prst="rect">
-            <a:avLst/>
-          </a:prstGeom>
-          <a:noFill/>
-        </p:spPr>
-        <p:txBody>
-          <a:bodyPr wrap="none">
-            <a:spAutoFit/>
-          </a:bodyPr>
-          <a:lstStyle/>
-          <a:p>
-            <a:pPr>
-              <a:defRPr sz="3200" b="1"/>
-            </a:pPr>
-            <a:r>
-              <a:t>Thank You!</a:t>
-            </a:r>
-          </a:p>
-        </p:txBody>
-      </p:sp>
-      <p:sp>
-        <p:nvSpPr>
-          <p:cNvPr id="3" name="TextBox 2"/>
-          <p:cNvSpPr txBox="1"/>
-          <p:nvPr/>
-        </p:nvSpPr>
-        <p:spPr>
-          <a:xfrm>
-            <a:off x="457200" y="914400"/>
-            <a:ext cx="8229600" cy="4572000"/>
-          </a:xfrm>
-          <a:prstGeom prst="rect">
-            <a:avLst/>
-          </a:prstGeom>
-          <a:noFill/>
-        </p:spPr>
-        <p:txBody>
-          <a:bodyPr wrap="square">
-            <a:spAutoFit/>
-          </a:bodyPr>
-          <a:lstStyle/>
-          <a:p>
-            <a:pPr>
-              <a:spcBef>
-                <a:spcPts val="800"/>
-              </a:spcBef>
-              <a:spcAft>
-                <a:spcPts val="400"/>
-              </a:spcAft>
-              <a:defRPr sz="2000"/>
-            </a:pPr>
-            <a:r>
-              <a:t>• Questions?</a:t>
-            </a:r>
-          </a:p>
-          <a:p>
-            <a:pPr>
-              <a:spcBef>
-                <a:spcPts val="800"/>
-              </a:spcBef>
-              <a:spcAft>
-                <a:spcPts val="400"/>
-              </a:spcAft>
-              <a:defRPr sz="2000"/>
-            </a:pPr>
-            <a:r>
-              <a:t>• </a:t>
-            </a:r>
-          </a:p>
-          <a:p>
-            <a:pPr>
-              <a:spcBef>
-                <a:spcPts val="800"/>
-              </a:spcBef>
-              <a:spcAft>
-                <a:spcPts val="400"/>
-              </a:spcAft>
-              <a:defRPr sz="2000"/>
-            </a:pPr>
-            <a:r>
-              <a:t>• Team Brain_Oil</a:t>
-            </a:r>
-          </a:p>
-          <a:p>
-            <a:pPr>
-              <a:spcBef>
-                <a:spcPts val="800"/>
-              </a:spcBef>
-              <a:spcAft>
-                <a:spcPts val="400"/>
-              </a:spcAft>
-              <a:defRPr sz="2000"/>
-            </a:pPr>
-            <a:r>
-              <a:t>• The University of Texas at Austin</a:t>
-            </a:r>
-          </a:p>
-          <a:p>
-            <a:pPr>
-              <a:spcBef>
-                <a:spcPts val="800"/>
-              </a:spcBef>
-              <a:spcAft>
-                <a:spcPts val="400"/>
-              </a:spcAft>
-              <a:defRPr sz="2000"/>
-            </a:pPr>
-            <a:r>
-              <a:t>• Energy AI Hackathon 2026</a:t>
-            </a:r>
-          </a:p>
-        </p:txBody>
-      </p:sp>
-    </p:spTree>
-  </p:cSld>
-  <p:clrMapOvr>
-    <a:masterClrMapping/>
-  </p:clrMapOvr>
-</p:sld>
-</file>
-
-<file path=ppt/slides/slide15.xml><?xml version="1.0" encoding="utf-8"?>
-<p:sld xmlns:a="http://schemas.openxmlformats.org/drawingml/2006/main" xmlns:p="http://schemas.openxmlformats.org/presentationml/2006/main" xmlns:r="http://schemas.openxmlformats.org/officeDocument/2006/relationships">
-  <p:cSld>
-    <p:spTree>
-      <p:nvGrpSpPr>
-        <p:cNvPr id="1" name=""/>
-        <p:cNvGrpSpPr/>
-        <p:nvPr/>
-      </p:nvGrpSpPr>
-      <p:grpSpPr/>
-      <p:sp>
-        <p:nvSpPr>
-          <p:cNvPr id="2" name="Title 1"/>
-          <p:cNvSpPr>
-            <a:spLocks noGrp="1"/>
-          </p:cNvSpPr>
-          <p:nvPr>
-            <p:ph type="title"/>
-          </p:nvPr>
-        </p:nvSpPr>
-        <p:spPr/>
-        <p:txBody>
-          <a:bodyPr/>
-          <a:lstStyle/>
-          <a:p/>
-        </p:txBody>
-      </p:sp>
-      <p:sp>
-        <p:nvSpPr>
-          <p:cNvPr id="3" name="TextBox 2"/>
-          <p:cNvSpPr txBox="1"/>
-          <p:nvPr/>
-        </p:nvSpPr>
-        <p:spPr>
-          <a:xfrm>
-            <a:off x="457200" y="274320"/>
-            <a:ext cx="8229600" cy="731520"/>
-          </a:xfrm>
-          <a:prstGeom prst="rect">
-            <a:avLst/>
-          </a:prstGeom>
-          <a:noFill/>
-        </p:spPr>
-        <p:txBody>
-          <a:bodyPr wrap="none">
-            <a:spAutoFit/>
-          </a:bodyPr>
-          <a:lstStyle/>
-          <a:p>
             <a:pPr algn="ctr">
-              <a:defRPr sz="2800" b="1"/>
-            </a:pPr>
-            <a:r>
-              <a:t>Spatial Analysis: Sand Proportion &amp; Production</a:t>
-            </a:r>
-          </a:p>
-        </p:txBody>
-      </p:sp>
-      <p:pic>
-        <p:nvPicPr>
-          <p:cNvPr id="4" name="Picture 3" descr="sand_heat_map.png"/>
-          <p:cNvPicPr>
-            <a:picLocks noChangeAspect="1"/>
-          </p:cNvPicPr>
-          <p:nvPr/>
-        </p:nvPicPr>
-        <p:blipFill>
-          <a:blip r:embed="rId2"/>
-          <a:stretch>
-            <a:fillRect/>
-          </a:stretch>
-        </p:blipFill>
-        <p:spPr>
-          <a:xfrm>
-            <a:off x="1371600" y="1097280"/>
-            <a:ext cx="6400800" cy="4846320"/>
-          </a:xfrm>
-          <a:prstGeom prst="rect">
-            <a:avLst/>
-          </a:prstGeom>
-        </p:spPr>
-      </p:pic>
-      <p:sp>
-        <p:nvSpPr>
-          <p:cNvPr id="5" name="TextBox 4"/>
-          <p:cNvSpPr txBox="1"/>
-          <p:nvPr/>
-        </p:nvSpPr>
-        <p:spPr>
-          <a:xfrm>
-            <a:off x="274320" y="6035040"/>
-            <a:ext cx="8595360" cy="548640"/>
-          </a:xfrm>
-          <a:prstGeom prst="rect">
-            <a:avLst/>
-          </a:prstGeom>
-          <a:noFill/>
-        </p:spPr>
-        <p:txBody>
-          <a:bodyPr wrap="none">
-            <a:spAutoFit/>
-          </a:bodyPr>
-          <a:lstStyle/>
-          <a:p>
-            <a:pPr algn="ctr">
-              <a:defRPr sz="1400" i="1"/>
-            </a:pPr>
-            <a:r>
-              <a:t>Key Insight: Higher sand proportion (yellow) correlates with higher oil production (green/yellow markers)</a:t>
+              <a:defRPr sz="1400"/>
+            </a:pPr>
+            <a:r>
+              <a:t>The University of Texas at Austin</a:t>
             </a:r>
           </a:p>
         </p:txBody>
@@ -4329,7 +3306,7 @@
         <p:spPr>
           <a:xfrm>
             <a:off x="457200" y="274320"/>
-            <a:ext cx="8229600" cy="731520"/>
+            <a:ext cx="8229600" cy="548640"/>
           </a:xfrm>
           <a:prstGeom prst="rect">
             <a:avLst/>
@@ -4360,7 +3337,7 @@
         <p:spPr>
           <a:xfrm>
             <a:off x="457200" y="914400"/>
-            <a:ext cx="8229600" cy="4572000"/>
+            <a:ext cx="8229600" cy="274320"/>
           </a:xfrm>
           <a:prstGeom prst="rect">
             <a:avLst/>
@@ -4368,64 +3345,249 @@
           <a:noFill/>
         </p:spPr>
         <p:txBody>
+          <a:bodyPr wrap="none">
+            <a:spAutoFit/>
+          </a:bodyPr>
+          <a:lstStyle/>
+          <a:p>
+            <a:pPr>
+              <a:defRPr sz="1600" b="1">
+                <a:solidFill>
+                  <a:srgbClr val="006699"/>
+                </a:solidFill>
+              </a:defRPr>
+            </a:pPr>
+            <a:r>
+              <a:t>1. The Problem</a:t>
+            </a:r>
+          </a:p>
+        </p:txBody>
+      </p:sp>
+      <p:sp>
+        <p:nvSpPr>
+          <p:cNvPr id="4" name="TextBox 3"/>
+          <p:cNvSpPr txBox="1"/>
+          <p:nvPr/>
+        </p:nvSpPr>
+        <p:spPr>
+          <a:xfrm>
+            <a:off x="457200" y="1188720"/>
+            <a:ext cx="8229600" cy="731520"/>
+          </a:xfrm>
+          <a:prstGeom prst="rect">
+            <a:avLst/>
+          </a:prstGeom>
+          <a:noFill/>
+        </p:spPr>
+        <p:txBody>
           <a:bodyPr wrap="square">
             <a:spAutoFit/>
           </a:bodyPr>
           <a:lstStyle/>
           <a:p>
             <a:pPr>
-              <a:spcBef>
-                <a:spcPts val="800"/>
-              </a:spcBef>
-              <a:spcAft>
-                <a:spcPts val="400"/>
-              </a:spcAft>
-              <a:defRPr sz="2000"/>
-            </a:pPr>
-            <a:r>
-              <a:t>• Problem: Predict 3-year cumulative oil production for 12 preproduction wells using well logs with missing data and noisy seismic maps</a:t>
-            </a:r>
-          </a:p>
-          <a:p>
-            <a:pPr>
-              <a:spcBef>
-                <a:spcPts val="800"/>
-              </a:spcBef>
-              <a:spcAft>
-                <a:spcPts val="400"/>
-              </a:spcAft>
-              <a:defRPr sz="2000"/>
-            </a:pPr>
-            <a:r>
-              <a:t>• Approach: MICE+CART imputation at depth level, 19+ engineered features (RQI, FZI), Ridge Regression with two-stage feature selection</a:t>
-            </a:r>
-          </a:p>
-          <a:p>
-            <a:pPr>
-              <a:spcBef>
-                <a:spcPts val="800"/>
-              </a:spcBef>
-              <a:spcAft>
-                <a:spcPts val="400"/>
-              </a:spcAft>
-              <a:defRPr sz="2000"/>
-            </a:pPr>
-            <a:r>
-              <a:t>• Findings: Ridge Regression outperformed tree-based models (R²=0.9905 vs ~0.82-0.85) due to lower variance on small datasets (n=71)</a:t>
-            </a:r>
-          </a:p>
-          <a:p>
-            <a:pPr>
-              <a:spcBef>
-                <a:spcPts val="800"/>
-              </a:spcBef>
-              <a:spcAft>
-                <a:spcPts val="400"/>
-              </a:spcAft>
-              <a:defRPr sz="2000"/>
-            </a:pPr>
-            <a:r>
-              <a:t>• Recommendation: For small subsurface datasets, prioritize regularized linear models over tree ensembles; use Bagging for uncertainty</a:t>
+              <a:defRPr sz="1400"/>
+            </a:pPr>
+            <a:r>
+              <a:t>Predict 3-year cumulative oil production for 12 preproduction wells (IDs 72-83) with uncertainty quantification (100 realizations).</a:t>
+            </a:r>
+          </a:p>
+        </p:txBody>
+      </p:sp>
+      <p:sp>
+        <p:nvSpPr>
+          <p:cNvPr id="5" name="TextBox 4"/>
+          <p:cNvSpPr txBox="1"/>
+          <p:nvPr/>
+        </p:nvSpPr>
+        <p:spPr>
+          <a:xfrm>
+            <a:off x="457200" y="2011680"/>
+            <a:ext cx="8229600" cy="274320"/>
+          </a:xfrm>
+          <a:prstGeom prst="rect">
+            <a:avLst/>
+          </a:prstGeom>
+          <a:noFill/>
+        </p:spPr>
+        <p:txBody>
+          <a:bodyPr wrap="none">
+            <a:spAutoFit/>
+          </a:bodyPr>
+          <a:lstStyle/>
+          <a:p>
+            <a:pPr>
+              <a:defRPr sz="1600" b="1">
+                <a:solidFill>
+                  <a:srgbClr val="006699"/>
+                </a:solidFill>
+              </a:defRPr>
+            </a:pPr>
+            <a:r>
+              <a:t>2. Our Solution</a:t>
+            </a:r>
+          </a:p>
+        </p:txBody>
+      </p:sp>
+      <p:sp>
+        <p:nvSpPr>
+          <p:cNvPr id="6" name="TextBox 5"/>
+          <p:cNvSpPr txBox="1"/>
+          <p:nvPr/>
+        </p:nvSpPr>
+        <p:spPr>
+          <a:xfrm>
+            <a:off x="457200" y="2286000"/>
+            <a:ext cx="8229600" cy="731520"/>
+          </a:xfrm>
+          <a:prstGeom prst="rect">
+            <a:avLst/>
+          </a:prstGeom>
+          <a:noFill/>
+        </p:spPr>
+        <p:txBody>
+          <a:bodyPr wrap="square">
+            <a:spAutoFit/>
+          </a:bodyPr>
+          <a:lstStyle/>
+          <a:p>
+            <a:pPr>
+              <a:defRPr sz="1400"/>
+            </a:pPr>
+            <a:r>
+              <a:t>Ridge Regression (alpha=1.0) with StandardScaler, stepwise feature selection (105→10), and Bagging Ensemble for uncertainty.</a:t>
+            </a:r>
+          </a:p>
+        </p:txBody>
+      </p:sp>
+      <p:sp>
+        <p:nvSpPr>
+          <p:cNvPr id="7" name="TextBox 6"/>
+          <p:cNvSpPr txBox="1"/>
+          <p:nvPr/>
+        </p:nvSpPr>
+        <p:spPr>
+          <a:xfrm>
+            <a:off x="457200" y="3108960"/>
+            <a:ext cx="8229600" cy="274320"/>
+          </a:xfrm>
+          <a:prstGeom prst="rect">
+            <a:avLst/>
+          </a:prstGeom>
+          <a:noFill/>
+        </p:spPr>
+        <p:txBody>
+          <a:bodyPr wrap="none">
+            <a:spAutoFit/>
+          </a:bodyPr>
+          <a:lstStyle/>
+          <a:p>
+            <a:pPr>
+              <a:defRPr sz="1600" b="1">
+                <a:solidFill>
+                  <a:srgbClr val="006699"/>
+                </a:solidFill>
+              </a:defRPr>
+            </a:pPr>
+            <a:r>
+              <a:t>3. What We Learned</a:t>
+            </a:r>
+          </a:p>
+        </p:txBody>
+      </p:sp>
+      <p:sp>
+        <p:nvSpPr>
+          <p:cNvPr id="8" name="TextBox 7"/>
+          <p:cNvSpPr txBox="1"/>
+          <p:nvPr/>
+        </p:nvSpPr>
+        <p:spPr>
+          <a:xfrm>
+            <a:off x="457200" y="3383280"/>
+            <a:ext cx="8229600" cy="731520"/>
+          </a:xfrm>
+          <a:prstGeom prst="rect">
+            <a:avLst/>
+          </a:prstGeom>
+          <a:noFill/>
+        </p:spPr>
+        <p:txBody>
+          <a:bodyPr wrap="square">
+            <a:spAutoFit/>
+          </a:bodyPr>
+          <a:lstStyle/>
+          <a:p>
+            <a:pPr>
+              <a:defRPr sz="1400"/>
+            </a:pPr>
+            <a:r>
+              <a:t>For small datasets (n=71), simple regularized models beat complex ones. Porosity (φ) is the primary driver of production.</a:t>
+            </a:r>
+          </a:p>
+        </p:txBody>
+      </p:sp>
+      <p:sp>
+        <p:nvSpPr>
+          <p:cNvPr id="9" name="TextBox 8"/>
+          <p:cNvSpPr txBox="1"/>
+          <p:nvPr/>
+        </p:nvSpPr>
+        <p:spPr>
+          <a:xfrm>
+            <a:off x="457200" y="4206240"/>
+            <a:ext cx="8229600" cy="274320"/>
+          </a:xfrm>
+          <a:prstGeom prst="rect">
+            <a:avLst/>
+          </a:prstGeom>
+          <a:noFill/>
+        </p:spPr>
+        <p:txBody>
+          <a:bodyPr wrap="none">
+            <a:spAutoFit/>
+          </a:bodyPr>
+          <a:lstStyle/>
+          <a:p>
+            <a:pPr>
+              <a:defRPr sz="1600" b="1">
+                <a:solidFill>
+                  <a:srgbClr val="006699"/>
+                </a:solidFill>
+              </a:defRPr>
+            </a:pPr>
+            <a:r>
+              <a:t>4. Our Results</a:t>
+            </a:r>
+          </a:p>
+        </p:txBody>
+      </p:sp>
+      <p:sp>
+        <p:nvSpPr>
+          <p:cNvPr id="10" name="TextBox 9"/>
+          <p:cNvSpPr txBox="1"/>
+          <p:nvPr/>
+        </p:nvSpPr>
+        <p:spPr>
+          <a:xfrm>
+            <a:off x="457200" y="4480560"/>
+            <a:ext cx="8229600" cy="731520"/>
+          </a:xfrm>
+          <a:prstGeom prst="rect">
+            <a:avLst/>
+          </a:prstGeom>
+          <a:noFill/>
+        </p:spPr>
+        <p:txBody>
+          <a:bodyPr wrap="square">
+            <a:spAutoFit/>
+          </a:bodyPr>
+          <a:lstStyle/>
+          <a:p>
+            <a:pPr>
+              <a:defRPr sz="1400"/>
+            </a:pPr>
+            <a:r>
+              <a:t>Test R² = 0.9905 (EXCELLENT), RMSE = 1.57M BBL (4.7% error). Ridge outperformed Random Forest and XGBoost.</a:t>
             </a:r>
           </a:p>
         </p:txBody>
@@ -4457,7 +3619,7 @@
         <p:spPr>
           <a:xfrm>
             <a:off x="457200" y="274320"/>
-            <a:ext cx="8229600" cy="731520"/>
+            <a:ext cx="8229600" cy="548640"/>
           </a:xfrm>
           <a:prstGeom prst="rect">
             <a:avLst/>
@@ -4474,7 +3636,7 @@
               <a:defRPr sz="3200" b="1"/>
             </a:pPr>
             <a:r>
-              <a:t>Problem Statement</a:t>
+              <a:t>Workflow Overview</a:t>
             </a:r>
           </a:p>
         </p:txBody>
@@ -4487,8 +3649,8 @@
         </p:nvSpPr>
         <p:spPr>
           <a:xfrm>
-            <a:off x="457200" y="914400"/>
-            <a:ext cx="8229600" cy="4572000"/>
+            <a:off x="365760" y="914400"/>
+            <a:ext cx="8412480" cy="5029200"/>
           </a:xfrm>
           <a:prstGeom prst="rect">
             <a:avLst/>
@@ -4503,57 +3665,99 @@
           <a:p>
             <a:pPr>
               <a:spcBef>
-                <a:spcPts val="800"/>
+                <a:spcPts val="1200"/>
               </a:spcBef>
               <a:spcAft>
                 <a:spcPts val="400"/>
               </a:spcAft>
-              <a:defRPr sz="2000"/>
-            </a:pPr>
-            <a:r>
-              <a:t>• Predict 3-year cumulative oil production (BBL) for 12 preproduction wells (IDs 72-83)</a:t>
+              <a:defRPr sz="1600"/>
+            </a:pPr>
+            <a:r>
+              <a:t>1. Data Loading → Load well logs (71 train, 12 test) + sand proportion map</a:t>
             </a:r>
           </a:p>
           <a:p>
             <a:pPr>
               <a:spcBef>
-                <a:spcPts val="800"/>
+                <a:spcPts val="1200"/>
               </a:spcBef>
               <a:spcAft>
                 <a:spcPts val="400"/>
               </a:spcAft>
-              <a:defRPr sz="2000"/>
-            </a:pPr>
-            <a:r>
-              <a:t>• Generate point estimates + 100 realizations for uncertainty quantification</a:t>
+              <a:defRPr sz="1600"/>
+            </a:pPr>
+            <a:r>
+              <a:t>2. MICE + CART Imputation → Fill missing values at depth level (Van Buuren 2018)</a:t>
             </a:r>
           </a:p>
           <a:p>
             <a:pPr>
               <a:spcBef>
-                <a:spcPts val="800"/>
+                <a:spcPts val="1200"/>
               </a:spcBef>
               <a:spcAft>
                 <a:spcPts val="400"/>
               </a:spcAft>
-              <a:defRPr sz="2000"/>
-            </a:pPr>
-            <a:r>
-              <a:t>• Training data: 71 production wells with ~21 depth measurements each</a:t>
+              <a:defRPr sz="1600"/>
+            </a:pPr>
+            <a:r>
+              <a:t>3. Aggregation → Multi-row depth data → One row per well (mean, std, min, max)</a:t>
             </a:r>
           </a:p>
           <a:p>
             <a:pPr>
               <a:spcBef>
-                <a:spcPts val="800"/>
+                <a:spcPts val="1200"/>
               </a:spcBef>
               <a:spcAft>
                 <a:spcPts val="400"/>
               </a:spcAft>
-              <a:defRPr sz="2000"/>
-            </a:pPr>
-            <a:r>
-              <a:t>• Challenges: Missing well log data, noisy seismic-derived sand map, small dataset size</a:t>
+              <a:defRPr sz="1600"/>
+            </a:pPr>
+            <a:r>
+              <a:t>4. Feature Engineering → 105 features including RQI, FZI, spatial features</a:t>
+            </a:r>
+          </a:p>
+          <a:p>
+            <a:pPr>
+              <a:spcBef>
+                <a:spcPts val="1200"/>
+              </a:spcBef>
+              <a:spcAft>
+                <a:spcPts val="400"/>
+              </a:spcAft>
+              <a:defRPr sz="1600"/>
+            </a:pPr>
+            <a:r>
+              <a:t>5. Feature Selection → Correlation filter (105→61) + Stepwise (61→10)</a:t>
+            </a:r>
+          </a:p>
+          <a:p>
+            <a:pPr>
+              <a:spcBef>
+                <a:spcPts val="1200"/>
+              </a:spcBef>
+              <a:spcAft>
+                <a:spcPts val="400"/>
+              </a:spcAft>
+              <a:defRPr sz="1600"/>
+            </a:pPr>
+            <a:r>
+              <a:t>6. Model Training → Ridge Regression with StandardScaler (alpha=1.0)</a:t>
+            </a:r>
+          </a:p>
+          <a:p>
+            <a:pPr>
+              <a:spcBef>
+                <a:spcPts val="1200"/>
+              </a:spcBef>
+              <a:spcAft>
+                <a:spcPts val="400"/>
+              </a:spcAft>
+              <a:defRPr sz="1600"/>
+            </a:pPr>
+            <a:r>
+              <a:t>7. Uncertainty → Bagging Ensemble (100 estimators) for R1-R100 realizations</a:t>
             </a:r>
           </a:p>
         </p:txBody>
@@ -4585,7 +3789,7 @@
         <p:spPr>
           <a:xfrm>
             <a:off x="457200" y="274320"/>
-            <a:ext cx="8229600" cy="731520"/>
+            <a:ext cx="8229600" cy="548640"/>
           </a:xfrm>
           <a:prstGeom prst="rect">
             <a:avLst/>
@@ -4602,7 +3806,7 @@
               <a:defRPr sz="3200" b="1"/>
             </a:pPr>
             <a:r>
-              <a:t>Data &amp; Preprocessing</a:t>
+              <a:t>Key Modeling Decisions</a:t>
             </a:r>
           </a:p>
         </p:txBody>
@@ -4615,8 +3819,8 @@
         </p:nvSpPr>
         <p:spPr>
           <a:xfrm>
-            <a:off x="457200" y="914400"/>
-            <a:ext cx="8229600" cy="4572000"/>
+            <a:off x="274320" y="914400"/>
+            <a:ext cx="4114800" cy="365760"/>
           </a:xfrm>
           <a:prstGeom prst="rect">
             <a:avLst/>
@@ -4624,6 +3828,41 @@
           <a:noFill/>
         </p:spPr>
         <p:txBody>
+          <a:bodyPr wrap="none">
+            <a:spAutoFit/>
+          </a:bodyPr>
+          <a:lstStyle/>
+          <a:p>
+            <a:pPr>
+              <a:defRPr sz="1800" b="1">
+                <a:solidFill>
+                  <a:srgbClr val="006699"/>
+                </a:solidFill>
+              </a:defRPr>
+            </a:pPr>
+            <a:r>
+              <a:t>Why Ridge Regression?</a:t>
+            </a:r>
+          </a:p>
+        </p:txBody>
+      </p:sp>
+      <p:sp>
+        <p:nvSpPr>
+          <p:cNvPr id="4" name="TextBox 3"/>
+          <p:cNvSpPr txBox="1"/>
+          <p:nvPr/>
+        </p:nvSpPr>
+        <p:spPr>
+          <a:xfrm>
+            <a:off x="274320" y="1280160"/>
+            <a:ext cx="4114800" cy="1828800"/>
+          </a:xfrm>
+          <a:prstGeom prst="rect">
+            <a:avLst/>
+          </a:prstGeom>
+          <a:noFill/>
+        </p:spPr>
+        <p:txBody>
           <a:bodyPr wrap="square">
             <a:spAutoFit/>
           </a:bodyPr>
@@ -4631,71 +3870,213 @@
           <a:p>
             <a:pPr>
               <a:spcBef>
-                <a:spcPts val="800"/>
+                <a:spcPts val="600"/>
               </a:spcBef>
-              <a:spcAft>
-                <a:spcPts val="400"/>
-              </a:spcAft>
-              <a:defRPr sz="2000"/>
-            </a:pPr>
-            <a:r>
-              <a:t>• Well log features: AI, SI, Vp, Vs, rho, K, G, phi, perm, GR, facies</a:t>
+              <a:defRPr sz="1400"/>
+            </a:pPr>
+            <a:r>
+              <a:t>• n=71 is small → regularized linear beats trees</a:t>
             </a:r>
           </a:p>
           <a:p>
             <a:pPr>
               <a:spcBef>
-                <a:spcPts val="800"/>
+                <a:spcPts val="600"/>
               </a:spcBef>
-              <a:spcAft>
-                <a:spcPts val="400"/>
-              </a:spcAft>
-              <a:defRPr sz="2000"/>
-            </a:pPr>
-            <a:r>
-              <a:t>• MICE + CART imputation at depth level (Van Buuren 2018, Hallam et al. 2022)</a:t>
+              <a:defRPr sz="1400"/>
+            </a:pPr>
+            <a:r>
+              <a:t>• Hastie et al. (2009): lower variance for small n</a:t>
             </a:r>
           </a:p>
           <a:p>
             <a:pPr>
               <a:spcBef>
-                <a:spcPts val="800"/>
+                <a:spcPts val="600"/>
               </a:spcBef>
-              <a:spcAft>
-                <a:spcPts val="400"/>
-              </a:spcAft>
-              <a:defRPr sz="2000"/>
-            </a:pPr>
-            <a:r>
-              <a:t>• Aggregation: Mean, std, min, max + best/worst zone features for depth heterogeneity</a:t>
+              <a:defRPr sz="1400"/>
+            </a:pPr>
+            <a:r>
+              <a:t>• Ridge R²=0.99 vs RF R²=0.85 vs XGB R²=0.82</a:t>
             </a:r>
           </a:p>
           <a:p>
             <a:pPr>
               <a:spcBef>
-                <a:spcPts val="800"/>
+                <a:spcPts val="600"/>
               </a:spcBef>
-              <a:spcAft>
-                <a:spcPts val="400"/>
-              </a:spcAft>
-              <a:defRPr sz="2000"/>
-            </a:pPr>
-            <a:r>
-              <a:t>• Sand map: 3x3 smoothing to reduce deliberate noise (per architect guidance)</a:t>
-            </a:r>
-          </a:p>
+              <a:defRPr sz="1400"/>
+            </a:pPr>
+            <a:r>
+              <a:t>• Alpha=1.0 provides balanced regularization</a:t>
+            </a:r>
+          </a:p>
+        </p:txBody>
+      </p:sp>
+      <p:sp>
+        <p:nvSpPr>
+          <p:cNvPr id="5" name="TextBox 4"/>
+          <p:cNvSpPr txBox="1"/>
+          <p:nvPr/>
+        </p:nvSpPr>
+        <p:spPr>
+          <a:xfrm>
+            <a:off x="4754880" y="914400"/>
+            <a:ext cx="4114800" cy="365760"/>
+          </a:xfrm>
+          <a:prstGeom prst="rect">
+            <a:avLst/>
+          </a:prstGeom>
+          <a:noFill/>
+        </p:spPr>
+        <p:txBody>
+          <a:bodyPr wrap="none">
+            <a:spAutoFit/>
+          </a:bodyPr>
+          <a:lstStyle/>
+          <a:p>
+            <a:pPr>
+              <a:defRPr sz="1800" b="1">
+                <a:solidFill>
+                  <a:srgbClr val="006699"/>
+                </a:solidFill>
+              </a:defRPr>
+            </a:pPr>
+            <a:r>
+              <a:t>Why Porosity (φ) Matters Most?</a:t>
+            </a:r>
+          </a:p>
+        </p:txBody>
+      </p:sp>
+      <p:sp>
+        <p:nvSpPr>
+          <p:cNvPr id="6" name="TextBox 5"/>
+          <p:cNvSpPr txBox="1"/>
+          <p:nvPr/>
+        </p:nvSpPr>
+        <p:spPr>
+          <a:xfrm>
+            <a:off x="4754880" y="1280160"/>
+            <a:ext cx="4114800" cy="1828800"/>
+          </a:xfrm>
+          <a:prstGeom prst="rect">
+            <a:avLst/>
+          </a:prstGeom>
+          <a:noFill/>
+        </p:spPr>
+        <p:txBody>
+          <a:bodyPr wrap="square">
+            <a:spAutoFit/>
+          </a:bodyPr>
+          <a:lstStyle/>
           <a:p>
             <a:pPr>
               <a:spcBef>
-                <a:spcPts val="800"/>
+                <a:spcPts val="600"/>
               </a:spcBef>
-              <a:spcAft>
-                <a:spcPts val="400"/>
-              </a:spcAft>
-              <a:defRPr sz="2000"/>
-            </a:pPr>
-            <a:r>
-              <a:t>• Production history: Calculate 3-year cumulative oil from monthly data</a:t>
+              <a:defRPr sz="1400"/>
+            </a:pPr>
+            <a:r>
+              <a:t>• φ directly measures storage capacity</a:t>
+            </a:r>
+          </a:p>
+          <a:p>
+            <a:pPr>
+              <a:spcBef>
+                <a:spcPts val="600"/>
+              </a:spcBef>
+              <a:defRPr sz="1400"/>
+            </a:pPr>
+            <a:r>
+              <a:t>• OOIP = 7758 × A × h × φ × (1-Sw) / Bo</a:t>
+            </a:r>
+          </a:p>
+          <a:p>
+            <a:pPr>
+              <a:spcBef>
+                <a:spcPts val="600"/>
+              </a:spcBef>
+              <a:defRPr sz="1400"/>
+            </a:pPr>
+            <a:r>
+              <a:t>• Higher porosity = more oil = more production</a:t>
+            </a:r>
+          </a:p>
+          <a:p>
+            <a:pPr>
+              <a:spcBef>
+                <a:spcPts val="600"/>
+              </a:spcBef>
+              <a:defRPr sz="1400"/>
+            </a:pPr>
+            <a:r>
+              <a:t>• Domain experts prioritize φ over k</a:t>
+            </a:r>
+          </a:p>
+        </p:txBody>
+      </p:sp>
+      <p:sp>
+        <p:nvSpPr>
+          <p:cNvPr id="7" name="TextBox 6"/>
+          <p:cNvSpPr txBox="1"/>
+          <p:nvPr/>
+        </p:nvSpPr>
+        <p:spPr>
+          <a:xfrm>
+            <a:off x="274320" y="3291840"/>
+            <a:ext cx="8229600" cy="365760"/>
+          </a:xfrm>
+          <a:prstGeom prst="rect">
+            <a:avLst/>
+          </a:prstGeom>
+          <a:noFill/>
+        </p:spPr>
+        <p:txBody>
+          <a:bodyPr wrap="none">
+            <a:spAutoFit/>
+          </a:bodyPr>
+          <a:lstStyle/>
+          <a:p>
+            <a:pPr>
+              <a:defRPr sz="1800" b="1">
+                <a:solidFill>
+                  <a:srgbClr val="006699"/>
+                </a:solidFill>
+              </a:defRPr>
+            </a:pPr>
+            <a:r>
+              <a:t>Final Configuration (57+ configs tested)</a:t>
+            </a:r>
+          </a:p>
+        </p:txBody>
+      </p:sp>
+      <p:sp>
+        <p:nvSpPr>
+          <p:cNvPr id="8" name="TextBox 7"/>
+          <p:cNvSpPr txBox="1"/>
+          <p:nvPr/>
+        </p:nvSpPr>
+        <p:spPr>
+          <a:xfrm>
+            <a:off x="274320" y="3657600"/>
+            <a:ext cx="8595360" cy="548640"/>
+          </a:xfrm>
+          <a:prstGeom prst="rect">
+            <a:avLst/>
+          </a:prstGeom>
+          <a:noFill/>
+        </p:spPr>
+        <p:txBody>
+          <a:bodyPr wrap="square">
+            <a:spAutoFit/>
+          </a:bodyPr>
+          <a:lstStyle/>
+          <a:p>
+            <a:pPr>
+              <a:defRPr sz="1400"/>
+            </a:pPr>
+            <a:r>
+              <a:t>Model: Ridge (α=1.0) | Normalize: StandardScaler | Features: 10 (stepwise) | Sand Map: Smooth 3x3 | Uncertainty: Bagging (100)</a:t>
             </a:r>
           </a:p>
         </p:txBody>
@@ -4727,7 +4108,7 @@
         <p:spPr>
           <a:xfrm>
             <a:off x="457200" y="274320"/>
-            <a:ext cx="8229600" cy="731520"/>
+            <a:ext cx="8229600" cy="548640"/>
           </a:xfrm>
           <a:prstGeom prst="rect">
             <a:avLst/>
@@ -4744,7 +4125,7 @@
               <a:defRPr sz="3200" b="1"/>
             </a:pPr>
             <a:r>
-              <a:t>Feature Engineering (19+ Features)</a:t>
+              <a:t>Results and Discussions</a:t>
             </a:r>
           </a:p>
         </p:txBody>
@@ -4757,8 +4138,8 @@
         </p:nvSpPr>
         <p:spPr>
           <a:xfrm>
-            <a:off x="457200" y="914400"/>
-            <a:ext cx="8229600" cy="4572000"/>
+            <a:off x="274320" y="914400"/>
+            <a:ext cx="4114800" cy="365760"/>
           </a:xfrm>
           <a:prstGeom prst="rect">
             <a:avLst/>
@@ -4766,6 +4147,41 @@
           <a:noFill/>
         </p:spPr>
         <p:txBody>
+          <a:bodyPr wrap="none">
+            <a:spAutoFit/>
+          </a:bodyPr>
+          <a:lstStyle/>
+          <a:p>
+            <a:pPr>
+              <a:defRPr sz="1800" b="1">
+                <a:solidFill>
+                  <a:srgbClr val="006699"/>
+                </a:solidFill>
+              </a:defRPr>
+            </a:pPr>
+            <a:r>
+              <a:t>Model Performance</a:t>
+            </a:r>
+          </a:p>
+        </p:txBody>
+      </p:sp>
+      <p:sp>
+        <p:nvSpPr>
+          <p:cNvPr id="4" name="TextBox 3"/>
+          <p:cNvSpPr txBox="1"/>
+          <p:nvPr/>
+        </p:nvSpPr>
+        <p:spPr>
+          <a:xfrm>
+            <a:off x="274320" y="1280160"/>
+            <a:ext cx="4114800" cy="1828800"/>
+          </a:xfrm>
+          <a:prstGeom prst="rect">
+            <a:avLst/>
+          </a:prstGeom>
+          <a:noFill/>
+        </p:spPr>
+        <p:txBody>
           <a:bodyPr wrap="square">
             <a:spAutoFit/>
           </a:bodyPr>
@@ -4773,85 +4189,213 @@
           <a:p>
             <a:pPr>
               <a:spcBef>
-                <a:spcPts val="800"/>
+                <a:spcPts val="600"/>
               </a:spcBef>
-              <a:spcAft>
-                <a:spcPts val="400"/>
-              </a:spcAft>
-              <a:defRPr sz="2000"/>
-            </a:pPr>
-            <a:r>
-              <a:t>• RQI = 0.0314 × √(k/φ) - Reservoir Quality Index (Amaefule et al. 1993)</a:t>
+              <a:defRPr sz="1400"/>
+            </a:pPr>
+            <a:r>
+              <a:t>• Test R² = 0.9905 (EXCELLENT ≥0.93)</a:t>
             </a:r>
           </a:p>
           <a:p>
             <a:pPr>
               <a:spcBef>
-                <a:spcPts val="800"/>
+                <a:spcPts val="600"/>
               </a:spcBef>
-              <a:spcAft>
-                <a:spcPts val="400"/>
-              </a:spcAft>
-              <a:defRPr sz="2000"/>
-            </a:pPr>
-            <a:r>
-              <a:t>• FZI = RQI / (φ/(1-φ)) - Flow Zone Indicator for hydraulic units</a:t>
+              <a:defRPr sz="1400"/>
+            </a:pPr>
+            <a:r>
+              <a:t>• CV R² = 0.9539 ± 0.0456 (stable)</a:t>
             </a:r>
           </a:p>
           <a:p>
             <a:pPr>
               <a:spcBef>
-                <a:spcPts val="800"/>
+                <a:spcPts val="600"/>
               </a:spcBef>
-              <a:spcAft>
-                <a:spcPts val="400"/>
-              </a:spcAft>
-              <a:defRPr sz="2000"/>
-            </a:pPr>
-            <a:r>
-              <a:t>• Vp/Vs ratio - Rock physics lithology and fluid indicator</a:t>
+              <a:defRPr sz="1400"/>
+            </a:pPr>
+            <a:r>
+              <a:t>• RMSE = 1.57M BBL (4.7% of mean)</a:t>
             </a:r>
           </a:p>
           <a:p>
             <a:pPr>
               <a:spcBef>
-                <a:spcPts val="800"/>
+                <a:spcPts val="600"/>
               </a:spcBef>
-              <a:spcAft>
-                <a:spcPts val="400"/>
-              </a:spcAft>
-              <a:defRPr sz="2000"/>
-            </a:pPr>
-            <a:r>
-              <a:t>• Best zone features: phi, perm, GR at depth with highest rock quality</a:t>
-            </a:r>
-          </a:p>
+              <a:defRPr sz="1400"/>
+            </a:pPr>
+            <a:r>
+              <a:t>• All metrics exceed industry benchmarks</a:t>
+            </a:r>
+          </a:p>
+        </p:txBody>
+      </p:sp>
+      <p:sp>
+        <p:nvSpPr>
+          <p:cNvPr id="5" name="TextBox 4"/>
+          <p:cNvSpPr txBox="1"/>
+          <p:nvPr/>
+        </p:nvSpPr>
+        <p:spPr>
+          <a:xfrm>
+            <a:off x="4754880" y="914400"/>
+            <a:ext cx="4114800" cy="365760"/>
+          </a:xfrm>
+          <a:prstGeom prst="rect">
+            <a:avLst/>
+          </a:prstGeom>
+          <a:noFill/>
+        </p:spPr>
+        <p:txBody>
+          <a:bodyPr wrap="none">
+            <a:spAutoFit/>
+          </a:bodyPr>
+          <a:lstStyle/>
+          <a:p>
+            <a:pPr>
+              <a:defRPr sz="1800" b="1">
+                <a:solidFill>
+                  <a:srgbClr val="006699"/>
+                </a:solidFill>
+              </a:defRPr>
+            </a:pPr>
+            <a:r>
+              <a:t>Predictions (Wells 72-83)</a:t>
+            </a:r>
+          </a:p>
+        </p:txBody>
+      </p:sp>
+      <p:sp>
+        <p:nvSpPr>
+          <p:cNvPr id="6" name="TextBox 5"/>
+          <p:cNvSpPr txBox="1"/>
+          <p:nvPr/>
+        </p:nvSpPr>
+        <p:spPr>
+          <a:xfrm>
+            <a:off x="4754880" y="1280160"/>
+            <a:ext cx="4114800" cy="1828800"/>
+          </a:xfrm>
+          <a:prstGeom prst="rect">
+            <a:avLst/>
+          </a:prstGeom>
+          <a:noFill/>
+        </p:spPr>
+        <p:txBody>
+          <a:bodyPr wrap="square">
+            <a:spAutoFit/>
+          </a:bodyPr>
+          <a:lstStyle/>
           <a:p>
             <a:pPr>
               <a:spcBef>
-                <a:spcPts val="800"/>
+                <a:spcPts val="600"/>
               </a:spcBef>
-              <a:spcAft>
-                <a:spcPts val="400"/>
-              </a:spcAft>
-              <a:defRPr sz="2000"/>
-            </a:pPr>
-            <a:r>
-              <a:t>• Analog similarity: Distance to top 25% producers in rock quality space</a:t>
+              <a:defRPr sz="1400"/>
+            </a:pPr>
+            <a:r>
+              <a:t>• 12 point estimates + 100 realizations each</a:t>
             </a:r>
           </a:p>
           <a:p>
             <a:pPr>
               <a:spcBef>
-                <a:spcPts val="800"/>
+                <a:spcPts val="600"/>
               </a:spcBef>
-              <a:spcAft>
-                <a:spcPts val="400"/>
-              </a:spcAft>
-              <a:defRPr sz="2000"/>
-            </a:pPr>
-            <a:r>
-              <a:t>• Spatial proximity: Distance to high-production region centroid</a:t>
+              <a:defRPr sz="1400"/>
+            </a:pPr>
+            <a:r>
+              <a:t>• Range: ~15M to ~47M BBL over 3 years</a:t>
+            </a:r>
+          </a:p>
+          <a:p>
+            <a:pPr>
+              <a:spcBef>
+                <a:spcPts val="600"/>
+              </a:spcBef>
+              <a:defRPr sz="1400"/>
+            </a:pPr>
+            <a:r>
+              <a:t>• Uncertainty via Bagging Ensemble</a:t>
+            </a:r>
+          </a:p>
+          <a:p>
+            <a:pPr>
+              <a:spcBef>
+                <a:spcPts val="600"/>
+              </a:spcBef>
+              <a:defRPr sz="1400"/>
+            </a:pPr>
+            <a:r>
+              <a:t>• Output: solution.csv (102 columns)</a:t>
+            </a:r>
+          </a:p>
+        </p:txBody>
+      </p:sp>
+      <p:sp>
+        <p:nvSpPr>
+          <p:cNvPr id="7" name="TextBox 6"/>
+          <p:cNvSpPr txBox="1"/>
+          <p:nvPr/>
+        </p:nvSpPr>
+        <p:spPr>
+          <a:xfrm>
+            <a:off x="274320" y="3200400"/>
+            <a:ext cx="8229600" cy="365760"/>
+          </a:xfrm>
+          <a:prstGeom prst="rect">
+            <a:avLst/>
+          </a:prstGeom>
+          <a:noFill/>
+        </p:spPr>
+        <p:txBody>
+          <a:bodyPr wrap="none">
+            <a:spAutoFit/>
+          </a:bodyPr>
+          <a:lstStyle/>
+          <a:p>
+            <a:pPr>
+              <a:defRPr sz="1800" b="1">
+                <a:solidFill>
+                  <a:srgbClr val="006699"/>
+                </a:solidFill>
+              </a:defRPr>
+            </a:pPr>
+            <a:r>
+              <a:t>Model Comparison (57+ configurations tested)</a:t>
+            </a:r>
+          </a:p>
+        </p:txBody>
+      </p:sp>
+      <p:sp>
+        <p:nvSpPr>
+          <p:cNvPr id="8" name="TextBox 7"/>
+          <p:cNvSpPr txBox="1"/>
+          <p:nvPr/>
+        </p:nvSpPr>
+        <p:spPr>
+          <a:xfrm>
+            <a:off x="274320" y="3566160"/>
+            <a:ext cx="8595360" cy="548640"/>
+          </a:xfrm>
+          <a:prstGeom prst="rect">
+            <a:avLst/>
+          </a:prstGeom>
+          <a:noFill/>
+        </p:spPr>
+        <p:txBody>
+          <a:bodyPr wrap="square">
+            <a:spAutoFit/>
+          </a:bodyPr>
+          <a:lstStyle/>
+          <a:p>
+            <a:pPr>
+              <a:defRPr sz="1400"/>
+            </a:pPr>
+            <a:r>
+              <a:t>Ridge R²=0.9905 (WINNER) | Random Forest R²=0.85 | XGBoost R²=0.82 | Linear Regression: Overfit</a:t>
             </a:r>
           </a:p>
         </p:txBody>
@@ -4883,7 +4427,7 @@
         <p:spPr>
           <a:xfrm>
             <a:off x="457200" y="274320"/>
-            <a:ext cx="8229600" cy="731520"/>
+            <a:ext cx="8229600" cy="548640"/>
           </a:xfrm>
           <a:prstGeom prst="rect">
             <a:avLst/>
@@ -4900,7 +4444,7 @@
               <a:defRPr sz="3200" b="1"/>
             </a:pPr>
             <a:r>
-              <a:t>Feature Selection (Two-Stage)</a:t>
+              <a:t>Feedback</a:t>
             </a:r>
           </a:p>
         </p:txBody>
@@ -4913,8 +4457,8 @@
         </p:nvSpPr>
         <p:spPr>
           <a:xfrm>
-            <a:off x="457200" y="914400"/>
-            <a:ext cx="8229600" cy="4572000"/>
+            <a:off x="274320" y="914400"/>
+            <a:ext cx="8229600" cy="365760"/>
           </a:xfrm>
           <a:prstGeom prst="rect">
             <a:avLst/>
@@ -4922,110 +4466,34 @@
           <a:noFill/>
         </p:spPr>
         <p:txBody>
-          <a:bodyPr wrap="square">
+          <a:bodyPr wrap="none">
             <a:spAutoFit/>
           </a:bodyPr>
           <a:lstStyle/>
           <a:p>
             <a:pPr>
-              <a:spcBef>
-                <a:spcPts val="800"/>
-              </a:spcBef>
-              <a:spcAft>
-                <a:spcPts val="400"/>
-              </a:spcAft>
-              <a:defRPr sz="2000"/>
-            </a:pPr>
-            <a:r>
-              <a:t>• Stage 1: Correlation filter removes redundant features (r ≥ 0.98)</a:t>
-            </a:r>
-          </a:p>
-          <a:p>
-            <a:pPr>
-              <a:spcBef>
-                <a:spcPts val="800"/>
-              </a:spcBef>
-              <a:spcAft>
-                <a:spcPts val="400"/>
-              </a:spcAft>
-              <a:defRPr sz="2000"/>
-            </a:pPr>
-            <a:r>
-              <a:t>• Result: 105 → 61 features (removed 44 highly correlated)</a:t>
-            </a:r>
-          </a:p>
-          <a:p>
-            <a:pPr>
-              <a:spcBef>
-                <a:spcPts val="800"/>
-              </a:spcBef>
-              <a:spcAft>
-                <a:spcPts val="400"/>
-              </a:spcAft>
-              <a:defRPr sz="2000"/>
-            </a:pPr>
-            <a:r>
-              <a:t>• Stage 2: Stepwise forward selection with 5-fold CV (Miller 2002)</a:t>
-            </a:r>
-          </a:p>
-          <a:p>
-            <a:pPr>
-              <a:spcBef>
-                <a:spcPts val="800"/>
-              </a:spcBef>
-              <a:spcAft>
-                <a:spcPts val="400"/>
-              </a:spcAft>
-              <a:defRPr sz="2000"/>
-            </a:pPr>
-            <a:r>
-              <a:t>• Result: 61 → 10 optimal features</a:t>
-            </a:r>
-          </a:p>
-          <a:p>
-            <a:pPr>
-              <a:spcBef>
-                <a:spcPts val="800"/>
-              </a:spcBef>
-              <a:spcAft>
-                <a:spcPts val="400"/>
-              </a:spcAft>
-              <a:defRPr sz="2000"/>
-            </a:pPr>
-            <a:r>
-              <a:t>• Key insight: Dimensionality reduction improves generalization (Guyon &amp; Elisseeff 2003)</a:t>
-            </a:r>
-          </a:p>
-        </p:txBody>
-      </p:sp>
-    </p:spTree>
-  </p:cSld>
-  <p:clrMapOvr>
-    <a:masterClrMapping/>
-  </p:clrMapOvr>
-</p:sld>
-</file>
-
-<file path=ppt/slides/slide7.xml><?xml version="1.0" encoding="utf-8"?>
-<p:sld xmlns:a="http://schemas.openxmlformats.org/drawingml/2006/main" xmlns:p="http://schemas.openxmlformats.org/presentationml/2006/main" xmlns:r="http://schemas.openxmlformats.org/officeDocument/2006/relationships">
-  <p:cSld>
-    <p:spTree>
-      <p:nvGrpSpPr>
-        <p:cNvPr id="1" name=""/>
-        <p:cNvGrpSpPr/>
-        <p:nvPr/>
-      </p:nvGrpSpPr>
-      <p:grpSpPr/>
-      <p:sp>
-        <p:nvSpPr>
-          <p:cNvPr id="2" name="TextBox 1"/>
+              <a:defRPr sz="1600" b="1">
+                <a:solidFill>
+                  <a:srgbClr val="006699"/>
+                </a:solidFill>
+              </a:defRPr>
+            </a:pPr>
+            <a:r>
+              <a:t>What We Learned</a:t>
+            </a:r>
+          </a:p>
+        </p:txBody>
+      </p:sp>
+      <p:sp>
+        <p:nvSpPr>
+          <p:cNvPr id="4" name="TextBox 3"/>
           <p:cNvSpPr txBox="1"/>
           <p:nvPr/>
         </p:nvSpPr>
         <p:spPr>
           <a:xfrm>
-            <a:off x="457200" y="274320"/>
-            <a:ext cx="8229600" cy="731520"/>
+            <a:off x="274320" y="1234440"/>
+            <a:ext cx="8595360" cy="1371600"/>
           </a:xfrm>
           <a:prstGeom prst="rect">
             <a:avLst/>
@@ -5033,30 +4501,66 @@
           <a:noFill/>
         </p:spPr>
         <p:txBody>
-          <a:bodyPr wrap="none">
+          <a:bodyPr wrap="square">
             <a:spAutoFit/>
           </a:bodyPr>
           <a:lstStyle/>
           <a:p>
             <a:pPr>
-              <a:defRPr sz="3200" b="1"/>
-            </a:pPr>
-            <a:r>
-              <a:t>Model Benchmarking Results</a:t>
-            </a:r>
-          </a:p>
-        </p:txBody>
-      </p:sp>
-      <p:sp>
-        <p:nvSpPr>
-          <p:cNvPr id="3" name="TextBox 2"/>
+              <a:spcBef>
+                <a:spcPts val="300"/>
+              </a:spcBef>
+              <a:defRPr sz="1300"/>
+            </a:pPr>
+            <a:r>
+              <a:t>• Simple models win for small datasets (n&lt;100)</a:t>
+            </a:r>
+          </a:p>
+          <a:p>
+            <a:pPr>
+              <a:spcBef>
+                <a:spcPts val="300"/>
+              </a:spcBef>
+              <a:defRPr sz="1300"/>
+            </a:pPr>
+            <a:r>
+              <a:t>• Domain knowledge (porosity priority) improves feature selection</a:t>
+            </a:r>
+          </a:p>
+          <a:p>
+            <a:pPr>
+              <a:spcBef>
+                <a:spcPts val="300"/>
+              </a:spcBef>
+              <a:defRPr sz="1300"/>
+            </a:pPr>
+            <a:r>
+              <a:t>• MICE+CART imputation preserves data relationships</a:t>
+            </a:r>
+          </a:p>
+          <a:p>
+            <a:pPr>
+              <a:spcBef>
+                <a:spcPts val="300"/>
+              </a:spcBef>
+              <a:defRPr sz="1300"/>
+            </a:pPr>
+            <a:r>
+              <a:t>• Bagging provides robust uncertainty quantification</a:t>
+            </a:r>
+          </a:p>
+        </p:txBody>
+      </p:sp>
+      <p:sp>
+        <p:nvSpPr>
+          <p:cNvPr id="5" name="TextBox 4"/>
           <p:cNvSpPr txBox="1"/>
           <p:nvPr/>
         </p:nvSpPr>
         <p:spPr>
           <a:xfrm>
-            <a:off x="457200" y="914400"/>
-            <a:ext cx="8229600" cy="457200"/>
+            <a:off x="274320" y="2788920"/>
+            <a:ext cx="8229600" cy="365760"/>
           </a:xfrm>
           <a:prstGeom prst="rect">
             <a:avLst/>
@@ -5070,380 +4574,28 @@
           <a:lstStyle/>
           <a:p>
             <a:pPr>
-              <a:defRPr sz="1800" i="1"/>
-            </a:pPr>
-            <a:r>
-              <a:t>Ridge Regression significantly outperformed tree-based models</a:t>
-            </a:r>
-          </a:p>
-        </p:txBody>
-      </p:sp>
-      <p:graphicFrame>
-        <p:nvGraphicFramePr>
-          <p:cNvPr id="4" name="Table 3"/>
-          <p:cNvGraphicFramePr>
-            <a:graphicFrameLocks noGrp="1"/>
-          </p:cNvGraphicFramePr>
-          <p:nvPr/>
-        </p:nvGraphicFramePr>
-        <p:xfrm>
-          <a:off x="457200" y="1371600"/>
-          <a:ext cx="8229600" cy="2286000"/>
-        </p:xfrm>
-        <a:graphic>
-          <a:graphicData uri="http://schemas.openxmlformats.org/drawingml/2006/table">
-            <a:tbl>
-              <a:tblPr firstRow="1" bandRow="1">
-                <a:tableStyleId>{5C22544A-7EE6-4342-B048-85BDC9FD1C3A}</a:tableStyleId>
-              </a:tblPr>
-              <a:tblGrid>
-                <a:gridCol w="2057400"/>
-                <a:gridCol w="2057400"/>
-                <a:gridCol w="2057400"/>
-                <a:gridCol w="2057400"/>
-              </a:tblGrid>
-              <a:tr h="457200">
-                <a:tc>
-                  <a:txBody>
-                    <a:bodyPr/>
-                    <a:lstStyle/>
-                    <a:p>
-                      <a:pPr>
-                        <a:defRPr b="1" sz="1400"/>
-                      </a:pPr>
-                      <a:r>
-                        <a:t>Model</a:t>
-                      </a:r>
-                    </a:p>
-                  </a:txBody>
-                  <a:tcPr/>
-                </a:tc>
-                <a:tc>
-                  <a:txBody>
-                    <a:bodyPr/>
-                    <a:lstStyle/>
-                    <a:p>
-                      <a:pPr>
-                        <a:defRPr b="1" sz="1400"/>
-                      </a:pPr>
-                      <a:r>
-                        <a:t>Test R²</a:t>
-                      </a:r>
-                    </a:p>
-                  </a:txBody>
-                  <a:tcPr/>
-                </a:tc>
-                <a:tc>
-                  <a:txBody>
-                    <a:bodyPr/>
-                    <a:lstStyle/>
-                    <a:p>
-                      <a:pPr>
-                        <a:defRPr b="1" sz="1400"/>
-                      </a:pPr>
-                      <a:r>
-                        <a:t>RMSE</a:t>
-                      </a:r>
-                    </a:p>
-                  </a:txBody>
-                  <a:tcPr/>
-                </a:tc>
-                <a:tc>
-                  <a:txBody>
-                    <a:bodyPr/>
-                    <a:lstStyle/>
-                    <a:p>
-                      <a:pPr>
-                        <a:defRPr b="1" sz="1400"/>
-                      </a:pPr>
-                      <a:r>
-                        <a:t>Overfitting Gap</a:t>
-                      </a:r>
-                    </a:p>
-                  </a:txBody>
-                  <a:tcPr/>
-                </a:tc>
-              </a:tr>
-              <a:tr h="457200">
-                <a:tc>
-                  <a:txBody>
-                    <a:bodyPr/>
-                    <a:lstStyle/>
-                    <a:p>
-                      <a:pPr>
-                        <a:defRPr sz="1200"/>
-                      </a:pPr>
-                      <a:r>
-                        <a:t>Ridge Regression</a:t>
-                      </a:r>
-                    </a:p>
-                  </a:txBody>
-                  <a:tcPr/>
-                </a:tc>
-                <a:tc>
-                  <a:txBody>
-                    <a:bodyPr/>
-                    <a:lstStyle/>
-                    <a:p>
-                      <a:pPr>
-                        <a:defRPr sz="1200"/>
-                      </a:pPr>
-                      <a:r>
-                        <a:t>0.9905</a:t>
-                      </a:r>
-                    </a:p>
-                  </a:txBody>
-                  <a:tcPr/>
-                </a:tc>
-                <a:tc>
-                  <a:txBody>
-                    <a:bodyPr/>
-                    <a:lstStyle/>
-                    <a:p>
-                      <a:pPr>
-                        <a:defRPr sz="1200"/>
-                      </a:pPr>
-                      <a:r>
-                        <a:t>1.57M BBL</a:t>
-                      </a:r>
-                    </a:p>
-                  </a:txBody>
-                  <a:tcPr/>
-                </a:tc>
-                <a:tc>
-                  <a:txBody>
-                    <a:bodyPr/>
-                    <a:lstStyle/>
-                    <a:p>
-                      <a:pPr>
-                        <a:defRPr sz="1200"/>
-                      </a:pPr>
-                      <a:r>
-                        <a:t>0.002</a:t>
-                      </a:r>
-                    </a:p>
-                  </a:txBody>
-                  <a:tcPr/>
-                </a:tc>
-              </a:tr>
-              <a:tr h="457200">
-                <a:tc>
-                  <a:txBody>
-                    <a:bodyPr/>
-                    <a:lstStyle/>
-                    <a:p>
-                      <a:pPr>
-                        <a:defRPr sz="1200"/>
-                      </a:pPr>
-                      <a:r>
-                        <a:t>Random Forest</a:t>
-                      </a:r>
-                    </a:p>
-                  </a:txBody>
-                  <a:tcPr/>
-                </a:tc>
-                <a:tc>
-                  <a:txBody>
-                    <a:bodyPr/>
-                    <a:lstStyle/>
-                    <a:p>
-                      <a:pPr>
-                        <a:defRPr sz="1200"/>
-                      </a:pPr>
-                      <a:r>
-                        <a:t>~0.85</a:t>
-                      </a:r>
-                    </a:p>
-                  </a:txBody>
-                  <a:tcPr/>
-                </a:tc>
-                <a:tc>
-                  <a:txBody>
-                    <a:bodyPr/>
-                    <a:lstStyle/>
-                    <a:p>
-                      <a:pPr>
-                        <a:defRPr sz="1200"/>
-                      </a:pPr>
-                      <a:r>
-                        <a:t>5.2M BBL</a:t>
-                      </a:r>
-                    </a:p>
-                  </a:txBody>
-                  <a:tcPr/>
-                </a:tc>
-                <a:tc>
-                  <a:txBody>
-                    <a:bodyPr/>
-                    <a:lstStyle/>
-                    <a:p>
-                      <a:pPr>
-                        <a:defRPr sz="1200"/>
-                      </a:pPr>
-                      <a:r>
-                        <a:t>0.15</a:t>
-                      </a:r>
-                    </a:p>
-                  </a:txBody>
-                  <a:tcPr/>
-                </a:tc>
-              </a:tr>
-              <a:tr h="457200">
-                <a:tc>
-                  <a:txBody>
-                    <a:bodyPr/>
-                    <a:lstStyle/>
-                    <a:p>
-                      <a:pPr>
-                        <a:defRPr sz="1200"/>
-                      </a:pPr>
-                      <a:r>
-                        <a:t>XGBoost</a:t>
-                      </a:r>
-                    </a:p>
-                  </a:txBody>
-                  <a:tcPr/>
-                </a:tc>
-                <a:tc>
-                  <a:txBody>
-                    <a:bodyPr/>
-                    <a:lstStyle/>
-                    <a:p>
-                      <a:pPr>
-                        <a:defRPr sz="1200"/>
-                      </a:pPr>
-                      <a:r>
-                        <a:t>~0.82</a:t>
-                      </a:r>
-                    </a:p>
-                  </a:txBody>
-                  <a:tcPr/>
-                </a:tc>
-                <a:tc>
-                  <a:txBody>
-                    <a:bodyPr/>
-                    <a:lstStyle/>
-                    <a:p>
-                      <a:pPr>
-                        <a:defRPr sz="1200"/>
-                      </a:pPr>
-                      <a:r>
-                        <a:t>5.8M BBL</a:t>
-                      </a:r>
-                    </a:p>
-                  </a:txBody>
-                  <a:tcPr/>
-                </a:tc>
-                <a:tc>
-                  <a:txBody>
-                    <a:bodyPr/>
-                    <a:lstStyle/>
-                    <a:p>
-                      <a:pPr>
-                        <a:defRPr sz="1200"/>
-                      </a:pPr>
-                      <a:r>
-                        <a:t>0.18</a:t>
-                      </a:r>
-                    </a:p>
-                  </a:txBody>
-                  <a:tcPr/>
-                </a:tc>
-              </a:tr>
-              <a:tr h="457200">
-                <a:tc>
-                  <a:txBody>
-                    <a:bodyPr/>
-                    <a:lstStyle/>
-                    <a:p>
-                      <a:pPr>
-                        <a:defRPr sz="1200"/>
-                      </a:pPr>
-                      <a:r>
-                        <a:t>Linear Regression</a:t>
-                      </a:r>
-                    </a:p>
-                  </a:txBody>
-                  <a:tcPr/>
-                </a:tc>
-                <a:tc>
-                  <a:txBody>
-                    <a:bodyPr/>
-                    <a:lstStyle/>
-                    <a:p>
-                      <a:pPr>
-                        <a:defRPr sz="1200"/>
-                      </a:pPr>
-                      <a:r>
-                        <a:t>Overfit</a:t>
-                      </a:r>
-                    </a:p>
-                  </a:txBody>
-                  <a:tcPr/>
-                </a:tc>
-                <a:tc>
-                  <a:txBody>
-                    <a:bodyPr/>
-                    <a:lstStyle/>
-                    <a:p>
-                      <a:pPr>
-                        <a:defRPr sz="1200"/>
-                      </a:pPr>
-                      <a:r>
-                        <a:t>-</a:t>
-                      </a:r>
-                    </a:p>
-                  </a:txBody>
-                  <a:tcPr/>
-                </a:tc>
-                <a:tc>
-                  <a:txBody>
-                    <a:bodyPr/>
-                    <a:lstStyle/>
-                    <a:p>
-                      <a:pPr>
-                        <a:defRPr sz="1200"/>
-                      </a:pPr>
-                      <a:r>
-                        <a:t>&gt;1.0</a:t>
-                      </a:r>
-                    </a:p>
-                  </a:txBody>
-                  <a:tcPr/>
-                </a:tc>
-              </a:tr>
-            </a:tbl>
-          </a:graphicData>
-        </a:graphic>
-      </p:graphicFrame>
-    </p:spTree>
-  </p:cSld>
-  <p:clrMapOvr>
-    <a:masterClrMapping/>
-  </p:clrMapOvr>
-</p:sld>
-</file>
-
-<file path=ppt/slides/slide8.xml><?xml version="1.0" encoding="utf-8"?>
-<p:sld xmlns:a="http://schemas.openxmlformats.org/drawingml/2006/main" xmlns:p="http://schemas.openxmlformats.org/presentationml/2006/main" xmlns:r="http://schemas.openxmlformats.org/officeDocument/2006/relationships">
-  <p:cSld>
-    <p:spTree>
-      <p:nvGrpSpPr>
-        <p:cNvPr id="1" name=""/>
-        <p:cNvGrpSpPr/>
-        <p:nvPr/>
-      </p:nvGrpSpPr>
-      <p:grpSpPr/>
-      <p:sp>
-        <p:nvSpPr>
-          <p:cNvPr id="2" name="TextBox 1"/>
+              <a:defRPr sz="1600" b="1">
+                <a:solidFill>
+                  <a:srgbClr val="006699"/>
+                </a:solidFill>
+              </a:defRPr>
+            </a:pPr>
+            <a:r>
+              <a:t>What We Liked</a:t>
+            </a:r>
+          </a:p>
+        </p:txBody>
+      </p:sp>
+      <p:sp>
+        <p:nvSpPr>
+          <p:cNvPr id="6" name="TextBox 5"/>
           <p:cNvSpPr txBox="1"/>
           <p:nvPr/>
         </p:nvSpPr>
         <p:spPr>
           <a:xfrm>
-            <a:off x="457200" y="274320"/>
-            <a:ext cx="8229600" cy="731520"/>
+            <a:off x="274320" y="3108960"/>
+            <a:ext cx="8595360" cy="1371600"/>
           </a:xfrm>
           <a:prstGeom prst="rect">
             <a:avLst/>
@@ -5451,30 +4603,55 @@
           <a:noFill/>
         </p:spPr>
         <p:txBody>
-          <a:bodyPr wrap="none">
+          <a:bodyPr wrap="square">
             <a:spAutoFit/>
           </a:bodyPr>
           <a:lstStyle/>
           <a:p>
             <a:pPr>
-              <a:defRPr sz="3200" b="1"/>
-            </a:pPr>
-            <a:r>
-              <a:t>Why Ridge Regression Won</a:t>
-            </a:r>
-          </a:p>
-        </p:txBody>
-      </p:sp>
-      <p:sp>
-        <p:nvSpPr>
-          <p:cNvPr id="3" name="TextBox 2"/>
+              <a:spcBef>
+                <a:spcPts val="300"/>
+              </a:spcBef>
+              <a:defRPr sz="1300"/>
+            </a:pPr>
+            <a:r>
+              <a:t>• Real-world petroleum engineering problem</a:t>
+            </a:r>
+          </a:p>
+          <a:p>
+            <a:pPr>
+              <a:spcBef>
+                <a:spcPts val="300"/>
+              </a:spcBef>
+              <a:defRPr sz="1300"/>
+            </a:pPr>
+            <a:r>
+              <a:t>• Comprehensive workshop materials (Prof. Pyrcz &amp; Prof. Foster)</a:t>
+            </a:r>
+          </a:p>
+          <a:p>
+            <a:pPr>
+              <a:spcBef>
+                <a:spcPts val="300"/>
+              </a:spcBef>
+              <a:defRPr sz="1300"/>
+            </a:pPr>
+            <a:r>
+              <a:t>• Multi-disciplinary team collaboration opportunity</a:t>
+            </a:r>
+          </a:p>
+        </p:txBody>
+      </p:sp>
+      <p:sp>
+        <p:nvSpPr>
+          <p:cNvPr id="7" name="TextBox 6"/>
           <p:cNvSpPr txBox="1"/>
           <p:nvPr/>
         </p:nvSpPr>
         <p:spPr>
           <a:xfrm>
-            <a:off x="457200" y="914400"/>
-            <a:ext cx="8229600" cy="4572000"/>
+            <a:off x="274320" y="4343400"/>
+            <a:ext cx="8229600" cy="365760"/>
           </a:xfrm>
           <a:prstGeom prst="rect">
             <a:avLst/>
@@ -5482,110 +4659,34 @@
           <a:noFill/>
         </p:spPr>
         <p:txBody>
-          <a:bodyPr wrap="square">
+          <a:bodyPr wrap="none">
             <a:spAutoFit/>
           </a:bodyPr>
           <a:lstStyle/>
           <a:p>
             <a:pPr>
-              <a:spcBef>
-                <a:spcPts val="800"/>
-              </a:spcBef>
-              <a:spcAft>
-                <a:spcPts val="400"/>
-              </a:spcAft>
-              <a:defRPr sz="2000"/>
-            </a:pPr>
-            <a:r>
-              <a:t>• Small dataset (n=71): Regularization prevents overfitting (Hastie et al. 2009)</a:t>
-            </a:r>
-          </a:p>
-          <a:p>
-            <a:pPr>
-              <a:spcBef>
-                <a:spcPts val="800"/>
-              </a:spcBef>
-              <a:spcAft>
-                <a:spcPts val="400"/>
-              </a:spcAft>
-              <a:defRPr sz="2000"/>
-            </a:pPr>
-            <a:r>
-              <a:t>• High-dimensional features: L2 penalty handles multicollinearity (Hoerl &amp; Kennard 1970)</a:t>
-            </a:r>
-          </a:p>
-          <a:p>
-            <a:pPr>
-              <a:spcBef>
-                <a:spcPts val="800"/>
-              </a:spcBef>
-              <a:spcAft>
-                <a:spcPts val="400"/>
-              </a:spcAft>
-              <a:defRPr sz="2000"/>
-            </a:pPr>
-            <a:r>
-              <a:t>• Stability: CV R² std of only ±0.0456 indicates robust performance</a:t>
-            </a:r>
-          </a:p>
-          <a:p>
-            <a:pPr>
-              <a:spcBef>
-                <a:spcPts val="800"/>
-              </a:spcBef>
-              <a:spcAft>
-                <a:spcPts val="400"/>
-              </a:spcAft>
-              <a:defRPr sz="2000"/>
-            </a:pPr>
-            <a:r>
-              <a:t>• Simplicity: Linear model is more interpretable than tree ensembles</a:t>
-            </a:r>
-          </a:p>
-          <a:p>
-            <a:pPr>
-              <a:spcBef>
-                <a:spcPts val="800"/>
-              </a:spcBef>
-              <a:spcAft>
-                <a:spcPts val="400"/>
-              </a:spcAft>
-              <a:defRPr sz="2000"/>
-            </a:pPr>
-            <a:r>
-              <a:t>• Key lesson: 'For small datasets, simpler models often win' - Dr. Pyrcz</a:t>
-            </a:r>
-          </a:p>
-        </p:txBody>
-      </p:sp>
-    </p:spTree>
-  </p:cSld>
-  <p:clrMapOvr>
-    <a:masterClrMapping/>
-  </p:clrMapOvr>
-</p:sld>
-</file>
-
-<file path=ppt/slides/slide9.xml><?xml version="1.0" encoding="utf-8"?>
-<p:sld xmlns:a="http://schemas.openxmlformats.org/drawingml/2006/main" xmlns:p="http://schemas.openxmlformats.org/presentationml/2006/main" xmlns:r="http://schemas.openxmlformats.org/officeDocument/2006/relationships">
-  <p:cSld>
-    <p:spTree>
-      <p:nvGrpSpPr>
-        <p:cNvPr id="1" name=""/>
-        <p:cNvGrpSpPr/>
-        <p:nvPr/>
-      </p:nvGrpSpPr>
-      <p:grpSpPr/>
-      <p:sp>
-        <p:nvSpPr>
-          <p:cNvPr id="2" name="TextBox 1"/>
+              <a:defRPr sz="1600" b="1">
+                <a:solidFill>
+                  <a:srgbClr val="006699"/>
+                </a:solidFill>
+              </a:defRPr>
+            </a:pPr>
+            <a:r>
+              <a:t>Suggestions for Next Year</a:t>
+            </a:r>
+          </a:p>
+        </p:txBody>
+      </p:sp>
+      <p:sp>
+        <p:nvSpPr>
+          <p:cNvPr id="8" name="TextBox 7"/>
           <p:cNvSpPr txBox="1"/>
           <p:nvPr/>
         </p:nvSpPr>
         <p:spPr>
           <a:xfrm>
-            <a:off x="457200" y="274320"/>
-            <a:ext cx="8229600" cy="731520"/>
+            <a:off x="274320" y="4663440"/>
+            <a:ext cx="8595360" cy="1371600"/>
           </a:xfrm>
           <a:prstGeom prst="rect">
             <a:avLst/>
@@ -5593,37 +4694,6 @@
           <a:noFill/>
         </p:spPr>
         <p:txBody>
-          <a:bodyPr wrap="none">
-            <a:spAutoFit/>
-          </a:bodyPr>
-          <a:lstStyle/>
-          <a:p>
-            <a:pPr>
-              <a:defRPr sz="3200" b="1"/>
-            </a:pPr>
-            <a:r>
-              <a:t>Uncertainty Quantification</a:t>
-            </a:r>
-          </a:p>
-        </p:txBody>
-      </p:sp>
-      <p:sp>
-        <p:nvSpPr>
-          <p:cNvPr id="3" name="TextBox 2"/>
-          <p:cNvSpPr txBox="1"/>
-          <p:nvPr/>
-        </p:nvSpPr>
-        <p:spPr>
-          <a:xfrm>
-            <a:off x="457200" y="914400"/>
-            <a:ext cx="8229600" cy="4572000"/>
-          </a:xfrm>
-          <a:prstGeom prst="rect">
-            <a:avLst/>
-          </a:prstGeom>
-          <a:noFill/>
-        </p:spPr>
-        <p:txBody>
           <a:bodyPr wrap="square">
             <a:spAutoFit/>
           </a:bodyPr>
@@ -5631,71 +4701,23 @@
           <a:p>
             <a:pPr>
               <a:spcBef>
-                <a:spcPts val="800"/>
+                <a:spcPts val="300"/>
               </a:spcBef>
-              <a:spcAft>
-                <a:spcPts val="400"/>
-              </a:spcAft>
-              <a:defRPr sz="2000"/>
-            </a:pPr>
-            <a:r>
-              <a:t>• Method: Bagging Ensemble with 100 Ridge estimators (Breiman 1996)</a:t>
+              <a:defRPr sz="1300"/>
+            </a:pPr>
+            <a:r>
+              <a:t>• More time for model validation and iteration</a:t>
             </a:r>
           </a:p>
           <a:p>
             <a:pPr>
               <a:spcBef>
-                <a:spcPts val="800"/>
+                <a:spcPts val="300"/>
               </a:spcBef>
-              <a:spcAft>
-                <a:spcPts val="400"/>
-              </a:spcAft>
-              <a:defRPr sz="2000"/>
-            </a:pPr>
-            <a:r>
-              <a:t>• Each estimator trained on bootstrap sample of training data</a:t>
-            </a:r>
-          </a:p>
-          <a:p>
-            <a:pPr>
-              <a:spcBef>
-                <a:spcPts val="800"/>
-              </a:spcBef>
-              <a:spcAft>
-                <a:spcPts val="400"/>
-              </a:spcAft>
-              <a:defRPr sz="2000"/>
-            </a:pPr>
-            <a:r>
-              <a:t>• Each estimator's prediction → one realization (R_1 to R_100)</a:t>
-            </a:r>
-          </a:p>
-          <a:p>
-            <a:pPr>
-              <a:spcBef>
-                <a:spcPts val="800"/>
-              </a:spcBef>
-              <a:spcAft>
-                <a:spcPts val="400"/>
-              </a:spcAft>
-              <a:defRPr sz="2000"/>
-            </a:pPr>
-            <a:r>
-              <a:t>• Captures model uncertainty, not just residual noise</a:t>
-            </a:r>
-          </a:p>
-          <a:p>
-            <a:pPr>
-              <a:spcBef>
-                <a:spcPts val="800"/>
-              </a:spcBef>
-              <a:spcAft>
-                <a:spcPts val="400"/>
-              </a:spcAft>
-              <a:defRPr sz="2000"/>
-            </a:pPr>
-            <a:r>
-              <a:t>• OOB R² validates ensemble quality without holdout data</a:t>
+              <a:defRPr sz="1300"/>
+            </a:pPr>
+            <a:r>
+              <a:t>• Additional spatial/temporal data for enhanced predictions</a:t>
             </a:r>
           </a:p>
         </p:txBody>

</xml_diff>